<commit_message>
Refine presentation language for management
</commit_message>
<xml_diff>
--- a/docs/SyncWorkTrack_Innovative_Demo.pptx
+++ b/docs/SyncWorkTrack_Innovative_Demo.pptx
@@ -2,17 +2,17 @@
 <file path=ppt/presentation.xml><?xml version="1.0" encoding="utf-8"?>
 <p:presentation xmlns:p="http://schemas.openxmlformats.org/presentationml/2006/main">
   <p:sldMasterIdLst>
-    <p:sldMasterId xmlns:r="http://schemas.openxmlformats.org/officeDocument/2006/relationships" id="2147483648" r:id="Rbe52b30fd61f4957"/>
+    <p:sldMasterId xmlns:r="http://schemas.openxmlformats.org/officeDocument/2006/relationships" id="2147483648" r:id="R78802fcf5ae14938"/>
   </p:sldMasterIdLst>
   <p:notesMasterIdLst>
-    <p:notesMasterId xmlns:r="http://schemas.openxmlformats.org/officeDocument/2006/relationships" r:id="R194ef11f69604177"/>
+    <p:notesMasterId xmlns:r="http://schemas.openxmlformats.org/officeDocument/2006/relationships" r:id="Rd04efdf481174925"/>
   </p:notesMasterIdLst>
   <p:sldIdLst>
-    <p:sldId xmlns:r="http://schemas.openxmlformats.org/officeDocument/2006/relationships" id="256" r:id="R9ff997d5c2154387"/>
-    <p:sldId xmlns:r="http://schemas.openxmlformats.org/officeDocument/2006/relationships" id="257" r:id="R5d45b610d2454d23"/>
-    <p:sldId xmlns:r="http://schemas.openxmlformats.org/officeDocument/2006/relationships" id="258" r:id="Rfe4dd4d606cd4962"/>
-    <p:sldId xmlns:r="http://schemas.openxmlformats.org/officeDocument/2006/relationships" id="259" r:id="Rd72139f0d4e64f76"/>
-    <p:sldId xmlns:r="http://schemas.openxmlformats.org/officeDocument/2006/relationships" id="260" r:id="Rb97fd1052faa4fc6"/>
+    <p:sldId xmlns:r="http://schemas.openxmlformats.org/officeDocument/2006/relationships" id="256" r:id="R80d17422d15f4b8e"/>
+    <p:sldId xmlns:r="http://schemas.openxmlformats.org/officeDocument/2006/relationships" id="257" r:id="Rf35924fac6b34c49"/>
+    <p:sldId xmlns:r="http://schemas.openxmlformats.org/officeDocument/2006/relationships" id="258" r:id="R67ba86df753b4e8e"/>
+    <p:sldId xmlns:r="http://schemas.openxmlformats.org/officeDocument/2006/relationships" id="259" r:id="R5efa6b7c7ed74f7a"/>
+    <p:sldId xmlns:r="http://schemas.openxmlformats.org/officeDocument/2006/relationships" id="260" r:id="R2fc3a44d482e46ce"/>
   </p:sldIdLst>
   <p:sldSz cx="12192000" cy="6858000"/>
   <p:notesSz cx="6858000" cy="9144000"/>
@@ -774,7 +774,7 @@
   </p:cSld>
   <p:clrMap bg1="lt1" tx1="dk1" bg2="lt2" tx2="dk2" accent1="accent1" accent2="accent2" accent3="accent3" accent4="accent4" accent5="accent5" accent6="accent6" hlink="hlink" folHlink="folHlink"/>
   <p:sldLayoutIdLst>
-    <p:sldLayoutId xmlns:r="http://schemas.openxmlformats.org/officeDocument/2006/relationships" id="2147483649" r:id="R9487c47ae60243a0"/>
+    <p:sldLayoutId xmlns:r="http://schemas.openxmlformats.org/officeDocument/2006/relationships" id="2147483649" r:id="Rd0100304b35249fc"/>
   </p:sldLayoutIdLst>
   <p:txStyles>
     <p:titleStyle>
@@ -1325,7 +1325,7 @@
           <p:cNvPr id="22" name="">
             <a:extLst xmlns:a="http://schemas.openxmlformats.org/drawingml/2006/main">
               <a:ext uri="{FF2B5EF4-FFF2-40B4-BE49-F238E27FC236}">
-                <a16:creationId xmlns:a16="http://schemas.microsoft.com/office/drawing/2014/main" id="{B44582E3-5D57-4A3D-AC09-F2989314B028}"/>
+                <a16:creationId xmlns:a16="http://schemas.microsoft.com/office/drawing/2014/main" id="{4E7682D8-3C11-4AD3-9330-CE9EC0181EBA}"/>
               </a:ext>
             </a:extLst>
           </p:cNvPr>
@@ -1355,7 +1355,7 @@
           <p:cNvPr id="2" name="">
             <a:extLst xmlns:a="http://schemas.openxmlformats.org/drawingml/2006/main">
               <a:ext uri="{FF2B5EF4-FFF2-40B4-BE49-F238E27FC236}">
-                <a16:creationId xmlns:a16="http://schemas.microsoft.com/office/drawing/2014/main" id="{C211020A-AFC6-4DAE-81D9-EBB1A8D7F057}"/>
+                <a16:creationId xmlns:a16="http://schemas.microsoft.com/office/drawing/2014/main" id="{EDD9D54C-8E24-4EE7-8E13-CAC6F7D45391}"/>
               </a:ext>
             </a:extLst>
           </p:cNvPr>
@@ -1412,7 +1412,7 @@
           <p:cNvPr id="3" name="">
             <a:extLst xmlns:a="http://schemas.openxmlformats.org/drawingml/2006/main">
               <a:ext uri="{FF2B5EF4-FFF2-40B4-BE49-F238E27FC236}">
-                <a16:creationId xmlns:a16="http://schemas.microsoft.com/office/drawing/2014/main" id="{914862F4-9CC3-4E1C-BBCC-65AE3D1BAD4E}"/>
+                <a16:creationId xmlns:a16="http://schemas.microsoft.com/office/drawing/2014/main" id="{44D165E5-A3A7-4F97-B76F-B25D547ADA02}"/>
               </a:ext>
             </a:extLst>
           </p:cNvPr>
@@ -1424,7 +1424,7 @@
         <p:spPr>
           <a:xfrm xmlns:a="http://schemas.openxmlformats.org/drawingml/2006/main">
             <a:off x="723900" y="1571625"/>
-            <a:ext cx="6572250" cy="1714500"/>
+            <a:ext cx="6858000" cy="1714500"/>
           </a:xfrm>
           <a:prstGeom xmlns:a="http://schemas.openxmlformats.org/drawingml/2006/main" prst="rect">
             <a:avLst/>
@@ -1441,7 +1441,7 @@
           <a:lstStyle xmlns:a="http://schemas.openxmlformats.org/drawingml/2006/main"/>
           <a:p xmlns:a="http://schemas.openxmlformats.org/drawingml/2006/main">
             <a:pPr algn="l">
-              <a:defRPr sz="3900" b="1">
+              <a:defRPr sz="3450" b="1">
                 <a:solidFill>
                   <a:srgbClr val="F8FBFF"/>
                 </a:solidFill>
@@ -1451,7 +1451,7 @@
               </a:defRPr>
             </a:pPr>
             <a:r>
-              <a:rPr sz="3900" b="1">
+              <a:rPr sz="3450" b="1">
                 <a:solidFill>
                   <a:srgbClr val="F8FBFF"/>
                 </a:solidFill>
@@ -1459,12 +1459,12 @@
                 <a:ea typeface="Aptos"/>
                 <a:cs typeface="Aptos"/>
               </a:rPr>
-              <a:t>One source.</a:t>
+              <a:t>Controlled synchronization</a:t>
             </a:r>
           </a:p>
           <a:p xmlns:a="http://schemas.openxmlformats.org/drawingml/2006/main">
             <a:pPr algn="l">
-              <a:defRPr sz="3900" b="1">
+              <a:defRPr sz="3450" b="1">
                 <a:solidFill>
                   <a:srgbClr val="F8FBFF"/>
                 </a:solidFill>
@@ -1474,7 +1474,7 @@
               </a:defRPr>
             </a:pPr>
             <a:r>
-              <a:rPr sz="3900" b="1">
+              <a:rPr sz="3450" b="1">
                 <a:solidFill>
                   <a:srgbClr val="F8FBFF"/>
                 </a:solidFill>
@@ -1482,7 +1482,7 @@
                 <a:ea typeface="Aptos"/>
                 <a:cs typeface="Aptos"/>
               </a:rPr>
-              <a:t>Every project aligned.</a:t>
+              <a:t>across Azure DevOps projects</a:t>
             </a:r>
           </a:p>
         </p:txBody>
@@ -1492,7 +1492,7 @@
           <p:cNvPr id="4" name="">
             <a:extLst xmlns:a="http://schemas.openxmlformats.org/drawingml/2006/main">
               <a:ext uri="{FF2B5EF4-FFF2-40B4-BE49-F238E27FC236}">
-                <a16:creationId xmlns:a16="http://schemas.microsoft.com/office/drawing/2014/main" id="{D4370119-9E97-4733-8641-17A631A5D7ED}"/>
+                <a16:creationId xmlns:a16="http://schemas.microsoft.com/office/drawing/2014/main" id="{02D6E10E-C02A-4A10-A1A9-4DE70FADEADE}"/>
               </a:ext>
             </a:extLst>
           </p:cNvPr>
@@ -1504,7 +1504,7 @@
         <p:spPr>
           <a:xfrm xmlns:a="http://schemas.openxmlformats.org/drawingml/2006/main">
             <a:off x="762000" y="3562350"/>
-            <a:ext cx="4953000" cy="400050"/>
+            <a:ext cx="6191250" cy="400050"/>
           </a:xfrm>
           <a:prstGeom xmlns:a="http://schemas.openxmlformats.org/drawingml/2006/main" prst="rect">
             <a:avLst/>
@@ -1521,7 +1521,7 @@
           <a:lstStyle xmlns:a="http://schemas.openxmlformats.org/drawingml/2006/main"/>
           <a:p xmlns:a="http://schemas.openxmlformats.org/drawingml/2006/main">
             <a:pPr algn="l">
-              <a:defRPr sz="1725" b="0">
+              <a:defRPr sz="1650" b="0">
                 <a:solidFill>
                   <a:srgbClr val="DCE8FF"/>
                 </a:solidFill>
@@ -1531,7 +1531,7 @@
               </a:defRPr>
             </a:pPr>
             <a:r>
-              <a:rPr sz="1725" b="0">
+              <a:rPr sz="1650" b="0">
                 <a:solidFill>
                   <a:srgbClr val="DCE8FF"/>
                 </a:solidFill>
@@ -1539,7 +1539,7 @@
                 <a:ea typeface="Aptos"/>
                 <a:cs typeface="Aptos"/>
               </a:rPr>
-              <a:t>Azure DevOps work items</a:t>
+              <a:t>One source project with multiple managed destinations</a:t>
             </a:r>
           </a:p>
         </p:txBody>
@@ -1549,7 +1549,7 @@
           <p:cNvPr id="5" name="">
             <a:extLst xmlns:a="http://schemas.openxmlformats.org/drawingml/2006/main">
               <a:ext uri="{FF2B5EF4-FFF2-40B4-BE49-F238E27FC236}">
-                <a16:creationId xmlns:a16="http://schemas.microsoft.com/office/drawing/2014/main" id="{6F486D23-53A9-4446-94BE-4383EA01C8FA}"/>
+                <a16:creationId xmlns:a16="http://schemas.microsoft.com/office/drawing/2014/main" id="{CB9C6600-A538-4809-A236-BC048D6E6E40}"/>
               </a:ext>
             </a:extLst>
           </p:cNvPr>
@@ -1579,7 +1579,7 @@
           <p:cNvPr id="6" name="">
             <a:extLst xmlns:a="http://schemas.openxmlformats.org/drawingml/2006/main">
               <a:ext uri="{FF2B5EF4-FFF2-40B4-BE49-F238E27FC236}">
-                <a16:creationId xmlns:a16="http://schemas.microsoft.com/office/drawing/2014/main" id="{8D4B2392-7703-4362-99EF-2E6234EF516F}"/>
+                <a16:creationId xmlns:a16="http://schemas.microsoft.com/office/drawing/2014/main" id="{6F54B57F-D828-45C5-A5E7-3884E341477B}"/>
               </a:ext>
             </a:extLst>
           </p:cNvPr>
@@ -1636,7 +1636,7 @@
           <p:cNvPr id="7" name="">
             <a:extLst xmlns:a="http://schemas.openxmlformats.org/drawingml/2006/main">
               <a:ext uri="{FF2B5EF4-FFF2-40B4-BE49-F238E27FC236}">
-                <a16:creationId xmlns:a16="http://schemas.microsoft.com/office/drawing/2014/main" id="{7465BE42-1DFA-4891-8315-EC70F8DBE151}"/>
+                <a16:creationId xmlns:a16="http://schemas.microsoft.com/office/drawing/2014/main" id="{612AB4C6-8FF2-4A70-9796-99CDBA1F0E5C}"/>
               </a:ext>
             </a:extLst>
           </p:cNvPr>
@@ -1666,7 +1666,7 @@
           <p:cNvPr id="8" name="">
             <a:extLst xmlns:a="http://schemas.openxmlformats.org/drawingml/2006/main">
               <a:ext uri="{FF2B5EF4-FFF2-40B4-BE49-F238E27FC236}">
-                <a16:creationId xmlns:a16="http://schemas.microsoft.com/office/drawing/2014/main" id="{A39A9FEE-F77E-4A90-9654-6B3EFCDC3DBB}"/>
+                <a16:creationId xmlns:a16="http://schemas.microsoft.com/office/drawing/2014/main" id="{1508CFC0-F3C5-434D-B017-612E13CB0E3E}"/>
               </a:ext>
             </a:extLst>
           </p:cNvPr>
@@ -1696,7 +1696,7 @@
           <p:cNvPr id="9" name="">
             <a:extLst xmlns:a="http://schemas.openxmlformats.org/drawingml/2006/main">
               <a:ext uri="{FF2B5EF4-FFF2-40B4-BE49-F238E27FC236}">
-                <a16:creationId xmlns:a16="http://schemas.microsoft.com/office/drawing/2014/main" id="{5037B4EB-EAB3-495D-AAD2-5334B6809B88}"/>
+                <a16:creationId xmlns:a16="http://schemas.microsoft.com/office/drawing/2014/main" id="{F53072B1-F06E-4C27-865F-11F874D9C6ED}"/>
               </a:ext>
             </a:extLst>
           </p:cNvPr>
@@ -1753,7 +1753,7 @@
           <p:cNvPr id="10" name="">
             <a:extLst xmlns:a="http://schemas.openxmlformats.org/drawingml/2006/main">
               <a:ext uri="{FF2B5EF4-FFF2-40B4-BE49-F238E27FC236}">
-                <a16:creationId xmlns:a16="http://schemas.microsoft.com/office/drawing/2014/main" id="{DC18F2D4-8CE6-4580-BAEE-CAF838D2E719}"/>
+                <a16:creationId xmlns:a16="http://schemas.microsoft.com/office/drawing/2014/main" id="{51BEAA3D-19C7-4B10-9345-0D10C63D19F7}"/>
               </a:ext>
             </a:extLst>
           </p:cNvPr>
@@ -1783,7 +1783,7 @@
           <p:cNvPr id="11" name="">
             <a:extLst xmlns:a="http://schemas.openxmlformats.org/drawingml/2006/main">
               <a:ext uri="{FF2B5EF4-FFF2-40B4-BE49-F238E27FC236}">
-                <a16:creationId xmlns:a16="http://schemas.microsoft.com/office/drawing/2014/main" id="{1E432B33-704F-4394-B2C1-2B90A13776DA}"/>
+                <a16:creationId xmlns:a16="http://schemas.microsoft.com/office/drawing/2014/main" id="{CECDC7EA-EA77-4042-86AF-3D096DFCEBF9}"/>
               </a:ext>
             </a:extLst>
           </p:cNvPr>
@@ -1813,7 +1813,7 @@
           <p:cNvPr id="12" name="">
             <a:extLst xmlns:a="http://schemas.openxmlformats.org/drawingml/2006/main">
               <a:ext uri="{FF2B5EF4-FFF2-40B4-BE49-F238E27FC236}">
-                <a16:creationId xmlns:a16="http://schemas.microsoft.com/office/drawing/2014/main" id="{36440207-3B71-4865-AC34-42D85FDA4BF5}"/>
+                <a16:creationId xmlns:a16="http://schemas.microsoft.com/office/drawing/2014/main" id="{A7700C7E-2EB9-42D0-B245-1E4D5B26A117}"/>
               </a:ext>
             </a:extLst>
           </p:cNvPr>
@@ -1870,7 +1870,7 @@
           <p:cNvPr id="13" name="">
             <a:extLst xmlns:a="http://schemas.openxmlformats.org/drawingml/2006/main">
               <a:ext uri="{FF2B5EF4-FFF2-40B4-BE49-F238E27FC236}">
-                <a16:creationId xmlns:a16="http://schemas.microsoft.com/office/drawing/2014/main" id="{D9A7A766-35ED-43D4-AF58-7C2048F6653F}"/>
+                <a16:creationId xmlns:a16="http://schemas.microsoft.com/office/drawing/2014/main" id="{1B9A0637-0A6A-4C58-AFC0-ABDE238E65C7}"/>
               </a:ext>
             </a:extLst>
           </p:cNvPr>
@@ -1900,7 +1900,7 @@
           <p:cNvPr id="14" name="">
             <a:extLst xmlns:a="http://schemas.openxmlformats.org/drawingml/2006/main">
               <a:ext uri="{FF2B5EF4-FFF2-40B4-BE49-F238E27FC236}">
-                <a16:creationId xmlns:a16="http://schemas.microsoft.com/office/drawing/2014/main" id="{426635FB-2AE1-4DFB-ACEC-611396DC4EB9}"/>
+                <a16:creationId xmlns:a16="http://schemas.microsoft.com/office/drawing/2014/main" id="{CC127254-9751-4A19-9B7F-D44B2B7A242C}"/>
               </a:ext>
             </a:extLst>
           </p:cNvPr>
@@ -1930,7 +1930,7 @@
           <p:cNvPr id="15" name="">
             <a:extLst xmlns:a="http://schemas.openxmlformats.org/drawingml/2006/main">
               <a:ext uri="{FF2B5EF4-FFF2-40B4-BE49-F238E27FC236}">
-                <a16:creationId xmlns:a16="http://schemas.microsoft.com/office/drawing/2014/main" id="{44C0E687-2BCF-4B96-898A-D07B7C7018FF}"/>
+                <a16:creationId xmlns:a16="http://schemas.microsoft.com/office/drawing/2014/main" id="{0BA26541-8016-4F6C-8870-23537608C0C4}"/>
               </a:ext>
             </a:extLst>
           </p:cNvPr>
@@ -1987,7 +1987,7 @@
           <p:cNvPr id="16" name="">
             <a:extLst xmlns:a="http://schemas.openxmlformats.org/drawingml/2006/main">
               <a:ext uri="{FF2B5EF4-FFF2-40B4-BE49-F238E27FC236}">
-                <a16:creationId xmlns:a16="http://schemas.microsoft.com/office/drawing/2014/main" id="{F13312D8-8B7A-40CB-A68C-D502CB77C00E}"/>
+                <a16:creationId xmlns:a16="http://schemas.microsoft.com/office/drawing/2014/main" id="{16D7501C-D2AE-44EF-9DE3-FA63C590B4F7}"/>
               </a:ext>
             </a:extLst>
           </p:cNvPr>
@@ -2017,7 +2017,7 @@
           <p:cNvPr id="17" name="">
             <a:extLst xmlns:a="http://schemas.openxmlformats.org/drawingml/2006/main">
               <a:ext uri="{FF2B5EF4-FFF2-40B4-BE49-F238E27FC236}">
-                <a16:creationId xmlns:a16="http://schemas.microsoft.com/office/drawing/2014/main" id="{5618078D-135F-431D-95BE-4304DCCD68D1}"/>
+                <a16:creationId xmlns:a16="http://schemas.microsoft.com/office/drawing/2014/main" id="{C1851AD0-7C2E-40A5-8B70-EC2092198638}"/>
               </a:ext>
             </a:extLst>
           </p:cNvPr>
@@ -2047,7 +2047,7 @@
           <p:cNvPr id="18" name="">
             <a:extLst xmlns:a="http://schemas.openxmlformats.org/drawingml/2006/main">
               <a:ext uri="{FF2B5EF4-FFF2-40B4-BE49-F238E27FC236}">
-                <a16:creationId xmlns:a16="http://schemas.microsoft.com/office/drawing/2014/main" id="{9F37E040-D791-4086-9DE3-9CC0DDDD7EF2}"/>
+                <a16:creationId xmlns:a16="http://schemas.microsoft.com/office/drawing/2014/main" id="{703E2F58-7805-4E37-B09F-55737C688BCC}"/>
               </a:ext>
             </a:extLst>
           </p:cNvPr>
@@ -2104,7 +2104,7 @@
           <p:cNvPr id="19" name="">
             <a:extLst xmlns:a="http://schemas.openxmlformats.org/drawingml/2006/main">
               <a:ext uri="{FF2B5EF4-FFF2-40B4-BE49-F238E27FC236}">
-                <a16:creationId xmlns:a16="http://schemas.microsoft.com/office/drawing/2014/main" id="{79D0C0A1-290E-4BEB-9B9E-5D91860734A9}"/>
+                <a16:creationId xmlns:a16="http://schemas.microsoft.com/office/drawing/2014/main" id="{9885FFA0-95A6-4897-BF90-31F55CEA62A5}"/>
               </a:ext>
             </a:extLst>
           </p:cNvPr>
@@ -2161,7 +2161,7 @@
           <p:cNvPr id="20" name="">
             <a:extLst xmlns:a="http://schemas.openxmlformats.org/drawingml/2006/main">
               <a:ext uri="{FF2B5EF4-FFF2-40B4-BE49-F238E27FC236}">
-                <a16:creationId xmlns:a16="http://schemas.microsoft.com/office/drawing/2014/main" id="{F7AB863F-D050-4408-973E-019A0C546A58}"/>
+                <a16:creationId xmlns:a16="http://schemas.microsoft.com/office/drawing/2014/main" id="{B1F3A55B-426D-4591-96C1-1B5A3E8B87B5}"/>
               </a:ext>
             </a:extLst>
           </p:cNvPr>
@@ -2173,7 +2173,7 @@
         <p:spPr>
           <a:xfrm xmlns:a="http://schemas.openxmlformats.org/drawingml/2006/main">
             <a:off x="742950" y="5810250"/>
-            <a:ext cx="5715000" cy="304800"/>
+            <a:ext cx="6191250" cy="304800"/>
           </a:xfrm>
           <a:prstGeom xmlns:a="http://schemas.openxmlformats.org/drawingml/2006/main" prst="rect">
             <a:avLst/>
@@ -2208,7 +2208,7 @@
                 <a:ea typeface="Aptos"/>
                 <a:cs typeface="Aptos"/>
               </a:rPr>
-              <a:t>Destination states stay untouched</a:t>
+              <a:t>Destination workflow states remain unchanged</a:t>
             </a:r>
           </a:p>
         </p:txBody>
@@ -2218,7 +2218,7 @@
           <p:cNvPr id="21" name="">
             <a:extLst xmlns:a="http://schemas.openxmlformats.org/drawingml/2006/main">
               <a:ext uri="{FF2B5EF4-FFF2-40B4-BE49-F238E27FC236}">
-                <a16:creationId xmlns:a16="http://schemas.microsoft.com/office/drawing/2014/main" id="{9C62AE63-F7FC-453A-964C-4859F7F24C18}"/>
+                <a16:creationId xmlns:a16="http://schemas.microsoft.com/office/drawing/2014/main" id="{1C5698CB-118B-4688-A59A-57700C6E362C}"/>
               </a:ext>
             </a:extLst>
           </p:cNvPr>
@@ -2273,7 +2273,7 @@
     </p:spTree>
     <p:extLst>
       <p:ext uri="{BB962C8B-B14F-4D97-AF65-F5344CB8AC3E}">
-        <p14:creationId xmlns:p14="http://schemas.microsoft.com/office/powerpoint/2010/main" val="1367965296"/>
+        <p14:creationId xmlns:p14="http://schemas.microsoft.com/office/powerpoint/2010/main" val="1354276972"/>
       </p:ext>
     </p:extLst>
   </p:cSld>
@@ -2304,7 +2304,7 @@
           <p:cNvPr id="21" name="">
             <a:extLst xmlns:a="http://schemas.openxmlformats.org/drawingml/2006/main">
               <a:ext uri="{FF2B5EF4-FFF2-40B4-BE49-F238E27FC236}">
-                <a16:creationId xmlns:a16="http://schemas.microsoft.com/office/drawing/2014/main" id="{F6B70CA7-5345-48AE-8F8B-C723D1A3AB90}"/>
+                <a16:creationId xmlns:a16="http://schemas.microsoft.com/office/drawing/2014/main" id="{DBAE3506-B788-489A-A22D-6CB5B5B868C0}"/>
               </a:ext>
             </a:extLst>
           </p:cNvPr>
@@ -2351,7 +2351,7 @@
                 <a:ea typeface="Aptos"/>
                 <a:cs typeface="Aptos"/>
               </a:rPr>
-              <a:t>Synchronization flow</a:t>
+              <a:t>Synchronization workflow</a:t>
             </a:r>
           </a:p>
         </p:txBody>
@@ -2361,7 +2361,7 @@
           <p:cNvPr id="2" name="">
             <a:extLst xmlns:a="http://schemas.openxmlformats.org/drawingml/2006/main">
               <a:ext uri="{FF2B5EF4-FFF2-40B4-BE49-F238E27FC236}">
-                <a16:creationId xmlns:a16="http://schemas.microsoft.com/office/drawing/2014/main" id="{5B3A73D0-0F67-43F9-9A79-8BD0CF102D28}"/>
+                <a16:creationId xmlns:a16="http://schemas.microsoft.com/office/drawing/2014/main" id="{6CCEBC38-4B6D-4AE3-ACBF-B7F12271CBA7}"/>
               </a:ext>
             </a:extLst>
           </p:cNvPr>
@@ -2391,7 +2391,7 @@
           <p:cNvPr id="3" name="">
             <a:extLst xmlns:a="http://schemas.openxmlformats.org/drawingml/2006/main">
               <a:ext uri="{FF2B5EF4-FFF2-40B4-BE49-F238E27FC236}">
-                <a16:creationId xmlns:a16="http://schemas.microsoft.com/office/drawing/2014/main" id="{E6AF61A1-9675-46AA-B06F-D025BCD4AA7C}"/>
+                <a16:creationId xmlns:a16="http://schemas.microsoft.com/office/drawing/2014/main" id="{6C618C78-721C-44EA-969B-CCC61F360F87}"/>
               </a:ext>
             </a:extLst>
           </p:cNvPr>
@@ -2421,7 +2421,7 @@
           <p:cNvPr id="4" name="">
             <a:extLst xmlns:a="http://schemas.openxmlformats.org/drawingml/2006/main">
               <a:ext uri="{FF2B5EF4-FFF2-40B4-BE49-F238E27FC236}">
-                <a16:creationId xmlns:a16="http://schemas.microsoft.com/office/drawing/2014/main" id="{47B9514D-A5E0-4754-92D6-CE9CA51235EE}"/>
+                <a16:creationId xmlns:a16="http://schemas.microsoft.com/office/drawing/2014/main" id="{44D4F9FB-902A-455D-8556-F3142F98C0F6}"/>
               </a:ext>
             </a:extLst>
           </p:cNvPr>
@@ -2478,7 +2478,7 @@
           <p:cNvPr id="5" name="">
             <a:extLst xmlns:a="http://schemas.openxmlformats.org/drawingml/2006/main">
               <a:ext uri="{FF2B5EF4-FFF2-40B4-BE49-F238E27FC236}">
-                <a16:creationId xmlns:a16="http://schemas.microsoft.com/office/drawing/2014/main" id="{E46520FF-50FB-4E6C-8E1D-829A440A25D3}"/>
+                <a16:creationId xmlns:a16="http://schemas.microsoft.com/office/drawing/2014/main" id="{DB38BEC1-388C-4645-A08D-66CC4F896CAD}"/>
               </a:ext>
             </a:extLst>
           </p:cNvPr>
@@ -2502,7 +2502,7 @@
         </p:spPr>
         <p:txBody>
           <a:bodyPr xmlns:a="http://schemas.openxmlformats.org/drawingml/2006/main" anchor="ctr">
-            <a:normAutofit fontScale="100000"/>
+            <a:normAutofit fontScale="81362"/>
           </a:bodyPr>
           <a:lstStyle xmlns:a="http://schemas.openxmlformats.org/drawingml/2006/main"/>
           <a:p xmlns:a="http://schemas.openxmlformats.org/drawingml/2006/main">
@@ -2525,7 +2525,7 @@
                 <a:ea typeface="Aptos"/>
                 <a:cs typeface="Aptos"/>
               </a:rPr>
-              <a:t>Select</a:t>
+              <a:t>Define scope</a:t>
             </a:r>
           </a:p>
         </p:txBody>
@@ -2535,7 +2535,7 @@
           <p:cNvPr id="6" name="">
             <a:extLst xmlns:a="http://schemas.openxmlformats.org/drawingml/2006/main">
               <a:ext uri="{FF2B5EF4-FFF2-40B4-BE49-F238E27FC236}">
-                <a16:creationId xmlns:a16="http://schemas.microsoft.com/office/drawing/2014/main" id="{3016D9F3-2B2E-429F-8699-020697CE896D}"/>
+                <a16:creationId xmlns:a16="http://schemas.microsoft.com/office/drawing/2014/main" id="{C361688A-3EC8-48F1-A1FD-D2544CD2F436}"/>
               </a:ext>
             </a:extLst>
           </p:cNvPr>
@@ -2582,7 +2582,7 @@
                 <a:ea typeface="Aptos"/>
                 <a:cs typeface="Aptos"/>
               </a:rPr>
-              <a:t>Choose source items</a:t>
+              <a:t>Select source work items</a:t>
             </a:r>
           </a:p>
         </p:txBody>
@@ -2592,7 +2592,7 @@
           <p:cNvPr id="7" name="">
             <a:extLst xmlns:a="http://schemas.openxmlformats.org/drawingml/2006/main">
               <a:ext uri="{FF2B5EF4-FFF2-40B4-BE49-F238E27FC236}">
-                <a16:creationId xmlns:a16="http://schemas.microsoft.com/office/drawing/2014/main" id="{E23BEBBE-3B0B-481E-AD65-7037D8A8D5E8}"/>
+                <a16:creationId xmlns:a16="http://schemas.microsoft.com/office/drawing/2014/main" id="{94C9BDE5-F30B-4BE5-9BE9-95C3EABAE474}"/>
               </a:ext>
             </a:extLst>
           </p:cNvPr>
@@ -2622,7 +2622,7 @@
           <p:cNvPr id="8" name="">
             <a:extLst xmlns:a="http://schemas.openxmlformats.org/drawingml/2006/main">
               <a:ext uri="{FF2B5EF4-FFF2-40B4-BE49-F238E27FC236}">
-                <a16:creationId xmlns:a16="http://schemas.microsoft.com/office/drawing/2014/main" id="{F2C81E58-BF42-450C-A32A-2C324A00E315}"/>
+                <a16:creationId xmlns:a16="http://schemas.microsoft.com/office/drawing/2014/main" id="{363E8E77-5A37-4DD7-850A-3E6A8DADC6D3}"/>
               </a:ext>
             </a:extLst>
           </p:cNvPr>
@@ -2679,7 +2679,7 @@
           <p:cNvPr id="9" name="">
             <a:extLst xmlns:a="http://schemas.openxmlformats.org/drawingml/2006/main">
               <a:ext uri="{FF2B5EF4-FFF2-40B4-BE49-F238E27FC236}">
-                <a16:creationId xmlns:a16="http://schemas.microsoft.com/office/drawing/2014/main" id="{9489788D-5407-4591-A3B4-97EA1996DA87}"/>
+                <a16:creationId xmlns:a16="http://schemas.microsoft.com/office/drawing/2014/main" id="{6CA0CB7C-DBA8-45AC-951F-C20DB08DA4E4}"/>
               </a:ext>
             </a:extLst>
           </p:cNvPr>
@@ -2726,7 +2726,7 @@
                 <a:ea typeface="Aptos"/>
                 <a:cs typeface="Aptos"/>
               </a:rPr>
-              <a:t>Preview</a:t>
+              <a:t>Review</a:t>
             </a:r>
           </a:p>
         </p:txBody>
@@ -2736,7 +2736,7 @@
           <p:cNvPr id="10" name="">
             <a:extLst xmlns:a="http://schemas.openxmlformats.org/drawingml/2006/main">
               <a:ext uri="{FF2B5EF4-FFF2-40B4-BE49-F238E27FC236}">
-                <a16:creationId xmlns:a16="http://schemas.microsoft.com/office/drawing/2014/main" id="{745F39B7-CF91-47FD-978A-9EA60BC783C0}"/>
+                <a16:creationId xmlns:a16="http://schemas.microsoft.com/office/drawing/2014/main" id="{5994C9B9-08FA-4B2E-B76A-C118370C1DD2}"/>
               </a:ext>
             </a:extLst>
           </p:cNvPr>
@@ -2783,7 +2783,7 @@
                 <a:ea typeface="Aptos"/>
                 <a:cs typeface="Aptos"/>
               </a:rPr>
-              <a:t>See create, change or up to date</a:t>
+              <a:t>Assess planned changes</a:t>
             </a:r>
           </a:p>
         </p:txBody>
@@ -2793,7 +2793,7 @@
           <p:cNvPr id="11" name="">
             <a:extLst xmlns:a="http://schemas.openxmlformats.org/drawingml/2006/main">
               <a:ext uri="{FF2B5EF4-FFF2-40B4-BE49-F238E27FC236}">
-                <a16:creationId xmlns:a16="http://schemas.microsoft.com/office/drawing/2014/main" id="{05CBDE16-CD34-4E5A-8F1A-91E8ECCC8185}"/>
+                <a16:creationId xmlns:a16="http://schemas.microsoft.com/office/drawing/2014/main" id="{2DF1062F-0B6B-4DEE-B217-A37C1B8D7D5A}"/>
               </a:ext>
             </a:extLst>
           </p:cNvPr>
@@ -2823,7 +2823,7 @@
           <p:cNvPr id="12" name="">
             <a:extLst xmlns:a="http://schemas.openxmlformats.org/drawingml/2006/main">
               <a:ext uri="{FF2B5EF4-FFF2-40B4-BE49-F238E27FC236}">
-                <a16:creationId xmlns:a16="http://schemas.microsoft.com/office/drawing/2014/main" id="{773C89A8-CC3A-421E-B83B-65E864C78204}"/>
+                <a16:creationId xmlns:a16="http://schemas.microsoft.com/office/drawing/2014/main" id="{D1678200-972B-4B81-98D9-E6BC367B3672}"/>
               </a:ext>
             </a:extLst>
           </p:cNvPr>
@@ -2880,7 +2880,7 @@
           <p:cNvPr id="13" name="">
             <a:extLst xmlns:a="http://schemas.openxmlformats.org/drawingml/2006/main">
               <a:ext uri="{FF2B5EF4-FFF2-40B4-BE49-F238E27FC236}">
-                <a16:creationId xmlns:a16="http://schemas.microsoft.com/office/drawing/2014/main" id="{3DE5F8ED-113D-4928-BABF-C673E313AB8D}"/>
+                <a16:creationId xmlns:a16="http://schemas.microsoft.com/office/drawing/2014/main" id="{80EE1FF4-6A42-4BAD-8C09-7E510E468CAB}"/>
               </a:ext>
             </a:extLst>
           </p:cNvPr>
@@ -2927,7 +2927,7 @@
                 <a:ea typeface="Aptos"/>
                 <a:cs typeface="Aptos"/>
               </a:rPr>
-              <a:t>Activate</a:t>
+              <a:t>Authorize</a:t>
             </a:r>
           </a:p>
         </p:txBody>
@@ -2937,7 +2937,7 @@
           <p:cNvPr id="14" name="">
             <a:extLst xmlns:a="http://schemas.openxmlformats.org/drawingml/2006/main">
               <a:ext uri="{FF2B5EF4-FFF2-40B4-BE49-F238E27FC236}">
-                <a16:creationId xmlns:a16="http://schemas.microsoft.com/office/drawing/2014/main" id="{0CEE4AA2-EA84-43AE-A0E4-54BA8A4AF005}"/>
+                <a16:creationId xmlns:a16="http://schemas.microsoft.com/office/drawing/2014/main" id="{84129AC7-3BAE-4EAE-94F7-FB1CBCA2CFB3}"/>
               </a:ext>
             </a:extLst>
           </p:cNvPr>
@@ -2984,7 +2984,7 @@
                 <a:ea typeface="Aptos"/>
                 <a:cs typeface="Aptos"/>
               </a:rPr>
-              <a:t>Unlock Azure writes</a:t>
+              <a:t>Enable Azure write operations</a:t>
             </a:r>
           </a:p>
         </p:txBody>
@@ -2994,7 +2994,7 @@
           <p:cNvPr id="15" name="">
             <a:extLst xmlns:a="http://schemas.openxmlformats.org/drawingml/2006/main">
               <a:ext uri="{FF2B5EF4-FFF2-40B4-BE49-F238E27FC236}">
-                <a16:creationId xmlns:a16="http://schemas.microsoft.com/office/drawing/2014/main" id="{585313CD-4C6C-469B-842F-4BA610836D2C}"/>
+                <a16:creationId xmlns:a16="http://schemas.microsoft.com/office/drawing/2014/main" id="{235C997F-A970-4A4E-AE2B-9B4B6826AC64}"/>
               </a:ext>
             </a:extLst>
           </p:cNvPr>
@@ -3024,7 +3024,7 @@
           <p:cNvPr id="16" name="">
             <a:extLst xmlns:a="http://schemas.openxmlformats.org/drawingml/2006/main">
               <a:ext uri="{FF2B5EF4-FFF2-40B4-BE49-F238E27FC236}">
-                <a16:creationId xmlns:a16="http://schemas.microsoft.com/office/drawing/2014/main" id="{1E26FFD0-D26B-4A26-A875-ED7298DA246C}"/>
+                <a16:creationId xmlns:a16="http://schemas.microsoft.com/office/drawing/2014/main" id="{5794981A-902F-42A9-B28C-1654947EAE99}"/>
               </a:ext>
             </a:extLst>
           </p:cNvPr>
@@ -3081,7 +3081,7 @@
           <p:cNvPr id="17" name="">
             <a:extLst xmlns:a="http://schemas.openxmlformats.org/drawingml/2006/main">
               <a:ext uri="{FF2B5EF4-FFF2-40B4-BE49-F238E27FC236}">
-                <a16:creationId xmlns:a16="http://schemas.microsoft.com/office/drawing/2014/main" id="{13A150BA-94DF-48B8-9860-3903DFCFEA87}"/>
+                <a16:creationId xmlns:a16="http://schemas.microsoft.com/office/drawing/2014/main" id="{78EDE35F-20F1-401E-AD6A-FD84A945B433}"/>
               </a:ext>
             </a:extLst>
           </p:cNvPr>
@@ -3128,7 +3128,7 @@
                 <a:ea typeface="Aptos"/>
                 <a:cs typeface="Aptos"/>
               </a:rPr>
-              <a:t>Sync</a:t>
+              <a:t>Execute</a:t>
             </a:r>
           </a:p>
         </p:txBody>
@@ -3138,7 +3138,7 @@
           <p:cNvPr id="18" name="">
             <a:extLst xmlns:a="http://schemas.openxmlformats.org/drawingml/2006/main">
               <a:ext uri="{FF2B5EF4-FFF2-40B4-BE49-F238E27FC236}">
-                <a16:creationId xmlns:a16="http://schemas.microsoft.com/office/drawing/2014/main" id="{867EE992-BCE2-4C82-848F-2E977234B0CC}"/>
+                <a16:creationId xmlns:a16="http://schemas.microsoft.com/office/drawing/2014/main" id="{EC4F4700-87D4-4847-BCE7-AC631346E037}"/>
               </a:ext>
             </a:extLst>
           </p:cNvPr>
@@ -3185,7 +3185,7 @@
                 <a:ea typeface="Aptos"/>
                 <a:cs typeface="Aptos"/>
               </a:rPr>
-              <a:t>Create or update mappings</a:t>
+              <a:t>Create or update mapped items</a:t>
             </a:r>
           </a:p>
         </p:txBody>
@@ -3195,7 +3195,7 @@
           <p:cNvPr id="19" name="">
             <a:extLst xmlns:a="http://schemas.openxmlformats.org/drawingml/2006/main">
               <a:ext uri="{FF2B5EF4-FFF2-40B4-BE49-F238E27FC236}">
-                <a16:creationId xmlns:a16="http://schemas.microsoft.com/office/drawing/2014/main" id="{0D2A7516-3AB0-4881-8AC6-C95A872A2D4D}"/>
+                <a16:creationId xmlns:a16="http://schemas.microsoft.com/office/drawing/2014/main" id="{E8A90F71-3597-4B05-A26D-8E0CE36989F6}"/>
               </a:ext>
             </a:extLst>
           </p:cNvPr>
@@ -3242,7 +3242,7 @@
                 <a:ea typeface="Aptos"/>
                 <a:cs typeface="Aptos"/>
               </a:rPr>
-              <a:t>Manual run or daily schedule</a:t>
+              <a:t>Manual execution or daily schedule</a:t>
             </a:r>
           </a:p>
         </p:txBody>
@@ -3252,7 +3252,7 @@
           <p:cNvPr id="20" name="">
             <a:extLst xmlns:a="http://schemas.openxmlformats.org/drawingml/2006/main">
               <a:ext uri="{FF2B5EF4-FFF2-40B4-BE49-F238E27FC236}">
-                <a16:creationId xmlns:a16="http://schemas.microsoft.com/office/drawing/2014/main" id="{FAD22673-1EE5-47F9-A58D-98051BBB6696}"/>
+                <a16:creationId xmlns:a16="http://schemas.microsoft.com/office/drawing/2014/main" id="{F5512495-E74D-4BC1-952D-2B1F432AACFA}"/>
               </a:ext>
             </a:extLst>
           </p:cNvPr>
@@ -3307,7 +3307,7 @@
     </p:spTree>
     <p:extLst>
       <p:ext uri="{BB962C8B-B14F-4D97-AF65-F5344CB8AC3E}">
-        <p14:creationId xmlns:p14="http://schemas.microsoft.com/office/powerpoint/2010/main" val="1440897174"/>
+        <p14:creationId xmlns:p14="http://schemas.microsoft.com/office/powerpoint/2010/main" val="2121690841"/>
       </p:ext>
     </p:extLst>
   </p:cSld>
@@ -3338,7 +3338,7 @@
           <p:cNvPr id="25" name="">
             <a:extLst xmlns:a="http://schemas.openxmlformats.org/drawingml/2006/main">
               <a:ext uri="{FF2B5EF4-FFF2-40B4-BE49-F238E27FC236}">
-                <a16:creationId xmlns:a16="http://schemas.microsoft.com/office/drawing/2014/main" id="{AE422D81-EC2E-4E32-82B2-D9BF2D3C4213}"/>
+                <a16:creationId xmlns:a16="http://schemas.microsoft.com/office/drawing/2014/main" id="{C5711578-8E82-4619-99D4-F6074D1809E8}"/>
               </a:ext>
             </a:extLst>
           </p:cNvPr>
@@ -3385,7 +3385,7 @@
                 <a:ea typeface="Aptos"/>
                 <a:cs typeface="Aptos"/>
               </a:rPr>
-              <a:t>Work items stay connected</a:t>
+              <a:t>Relationship preservation</a:t>
             </a:r>
           </a:p>
         </p:txBody>
@@ -3395,7 +3395,7 @@
           <p:cNvPr id="2" name="">
             <a:extLst xmlns:a="http://schemas.openxmlformats.org/drawingml/2006/main">
               <a:ext uri="{FF2B5EF4-FFF2-40B4-BE49-F238E27FC236}">
-                <a16:creationId xmlns:a16="http://schemas.microsoft.com/office/drawing/2014/main" id="{D57E7199-ED5D-4C29-AA17-EBA0D9EB043E}"/>
+                <a16:creationId xmlns:a16="http://schemas.microsoft.com/office/drawing/2014/main" id="{16E551CB-7040-4125-A274-114E0CAD795B}"/>
               </a:ext>
             </a:extLst>
           </p:cNvPr>
@@ -3452,7 +3452,7 @@
           <p:cNvPr id="3" name="">
             <a:extLst xmlns:a="http://schemas.openxmlformats.org/drawingml/2006/main">
               <a:ext uri="{FF2B5EF4-FFF2-40B4-BE49-F238E27FC236}">
-                <a16:creationId xmlns:a16="http://schemas.microsoft.com/office/drawing/2014/main" id="{933D3EF4-E464-4E7B-8EC5-257E571919B5}"/>
+                <a16:creationId xmlns:a16="http://schemas.microsoft.com/office/drawing/2014/main" id="{596E9DCD-9849-40D3-8037-9A0D6E56DC65}"/>
               </a:ext>
             </a:extLst>
           </p:cNvPr>
@@ -3509,7 +3509,7 @@
           <p:cNvPr id="4" name="">
             <a:extLst xmlns:a="http://schemas.openxmlformats.org/drawingml/2006/main">
               <a:ext uri="{FF2B5EF4-FFF2-40B4-BE49-F238E27FC236}">
-                <a16:creationId xmlns:a16="http://schemas.microsoft.com/office/drawing/2014/main" id="{96BBA01A-93AB-4653-B544-2CD7080DD132}"/>
+                <a16:creationId xmlns:a16="http://schemas.microsoft.com/office/drawing/2014/main" id="{CB9A424D-9591-4D3B-B228-B54C09DCE5DF}"/>
               </a:ext>
             </a:extLst>
           </p:cNvPr>
@@ -3539,7 +3539,7 @@
           <p:cNvPr id="5" name="">
             <a:extLst xmlns:a="http://schemas.openxmlformats.org/drawingml/2006/main">
               <a:ext uri="{FF2B5EF4-FFF2-40B4-BE49-F238E27FC236}">
-                <a16:creationId xmlns:a16="http://schemas.microsoft.com/office/drawing/2014/main" id="{CE6573AA-F7C5-4298-A7DE-62CEE194E3DE}"/>
+                <a16:creationId xmlns:a16="http://schemas.microsoft.com/office/drawing/2014/main" id="{FDD26A66-3DA2-460B-8DB9-1D3BC194A3FA}"/>
               </a:ext>
             </a:extLst>
           </p:cNvPr>
@@ -3596,7 +3596,7 @@
           <p:cNvPr id="6" name="">
             <a:extLst xmlns:a="http://schemas.openxmlformats.org/drawingml/2006/main">
               <a:ext uri="{FF2B5EF4-FFF2-40B4-BE49-F238E27FC236}">
-                <a16:creationId xmlns:a16="http://schemas.microsoft.com/office/drawing/2014/main" id="{3D82A0B5-BCF2-4D7A-824B-4F456A626B1C}"/>
+                <a16:creationId xmlns:a16="http://schemas.microsoft.com/office/drawing/2014/main" id="{D9F85C27-97A5-40E4-A6E5-12BF5B906591}"/>
               </a:ext>
             </a:extLst>
           </p:cNvPr>
@@ -3626,7 +3626,7 @@
           <p:cNvPr id="7" name="">
             <a:extLst xmlns:a="http://schemas.openxmlformats.org/drawingml/2006/main">
               <a:ext uri="{FF2B5EF4-FFF2-40B4-BE49-F238E27FC236}">
-                <a16:creationId xmlns:a16="http://schemas.microsoft.com/office/drawing/2014/main" id="{747FDB93-EB16-4755-A08C-2BE05A18BA62}"/>
+                <a16:creationId xmlns:a16="http://schemas.microsoft.com/office/drawing/2014/main" id="{C502001B-EDA7-4AE6-98F2-493BE2E0BD1B}"/>
               </a:ext>
             </a:extLst>
           </p:cNvPr>
@@ -3656,7 +3656,7 @@
           <p:cNvPr id="8" name="">
             <a:extLst xmlns:a="http://schemas.openxmlformats.org/drawingml/2006/main">
               <a:ext uri="{FF2B5EF4-FFF2-40B4-BE49-F238E27FC236}">
-                <a16:creationId xmlns:a16="http://schemas.microsoft.com/office/drawing/2014/main" id="{4CE566AA-E5DA-4F84-A901-74CF5070EEF8}"/>
+                <a16:creationId xmlns:a16="http://schemas.microsoft.com/office/drawing/2014/main" id="{D61DA2EB-C81C-4705-A01D-D2266AA9E1B8}"/>
               </a:ext>
             </a:extLst>
           </p:cNvPr>
@@ -3713,7 +3713,7 @@
           <p:cNvPr id="9" name="">
             <a:extLst xmlns:a="http://schemas.openxmlformats.org/drawingml/2006/main">
               <a:ext uri="{FF2B5EF4-FFF2-40B4-BE49-F238E27FC236}">
-                <a16:creationId xmlns:a16="http://schemas.microsoft.com/office/drawing/2014/main" id="{7C3EFB91-E29F-40D2-BE76-0872B0D013EB}"/>
+                <a16:creationId xmlns:a16="http://schemas.microsoft.com/office/drawing/2014/main" id="{006045F0-B73D-4FCA-BEDC-CBCB072308E4}"/>
               </a:ext>
             </a:extLst>
           </p:cNvPr>
@@ -3743,7 +3743,7 @@
           <p:cNvPr id="10" name="">
             <a:extLst xmlns:a="http://schemas.openxmlformats.org/drawingml/2006/main">
               <a:ext uri="{FF2B5EF4-FFF2-40B4-BE49-F238E27FC236}">
-                <a16:creationId xmlns:a16="http://schemas.microsoft.com/office/drawing/2014/main" id="{87C977C0-445F-4A34-A9DC-3AA2A56763DD}"/>
+                <a16:creationId xmlns:a16="http://schemas.microsoft.com/office/drawing/2014/main" id="{411935EB-A9BC-490B-9A4A-CFD832070A0A}"/>
               </a:ext>
             </a:extLst>
           </p:cNvPr>
@@ -3773,7 +3773,7 @@
           <p:cNvPr id="11" name="">
             <a:extLst xmlns:a="http://schemas.openxmlformats.org/drawingml/2006/main">
               <a:ext uri="{FF2B5EF4-FFF2-40B4-BE49-F238E27FC236}">
-                <a16:creationId xmlns:a16="http://schemas.microsoft.com/office/drawing/2014/main" id="{8948490A-6EA1-4EBF-B575-D3DFDE2E8F03}"/>
+                <a16:creationId xmlns:a16="http://schemas.microsoft.com/office/drawing/2014/main" id="{435D6D0C-35BA-4050-8274-90D3C7CB6677}"/>
               </a:ext>
             </a:extLst>
           </p:cNvPr>
@@ -3830,7 +3830,7 @@
           <p:cNvPr id="12" name="">
             <a:extLst xmlns:a="http://schemas.openxmlformats.org/drawingml/2006/main">
               <a:ext uri="{FF2B5EF4-FFF2-40B4-BE49-F238E27FC236}">
-                <a16:creationId xmlns:a16="http://schemas.microsoft.com/office/drawing/2014/main" id="{5B6ABC4E-EA11-46ED-8D92-ABFCE6D4C174}"/>
+                <a16:creationId xmlns:a16="http://schemas.microsoft.com/office/drawing/2014/main" id="{EFD599D2-D6EB-40E5-A3DD-6B9337B08190}"/>
               </a:ext>
             </a:extLst>
           </p:cNvPr>
@@ -3860,7 +3860,7 @@
           <p:cNvPr id="13" name="">
             <a:extLst xmlns:a="http://schemas.openxmlformats.org/drawingml/2006/main">
               <a:ext uri="{FF2B5EF4-FFF2-40B4-BE49-F238E27FC236}">
-                <a16:creationId xmlns:a16="http://schemas.microsoft.com/office/drawing/2014/main" id="{E2B28305-2C22-44C8-AB75-F02F428701FF}"/>
+                <a16:creationId xmlns:a16="http://schemas.microsoft.com/office/drawing/2014/main" id="{8A2CC3DF-0A42-495B-ACA1-E647ED7BACBC}"/>
               </a:ext>
             </a:extLst>
           </p:cNvPr>
@@ -3890,7 +3890,7 @@
           <p:cNvPr id="14" name="">
             <a:extLst xmlns:a="http://schemas.openxmlformats.org/drawingml/2006/main">
               <a:ext uri="{FF2B5EF4-FFF2-40B4-BE49-F238E27FC236}">
-                <a16:creationId xmlns:a16="http://schemas.microsoft.com/office/drawing/2014/main" id="{E682C626-3C64-4421-94E8-9A022577692D}"/>
+                <a16:creationId xmlns:a16="http://schemas.microsoft.com/office/drawing/2014/main" id="{AE3CF79E-B8B3-460D-AA35-4FC79C3D8374}"/>
               </a:ext>
             </a:extLst>
           </p:cNvPr>
@@ -3947,7 +3947,7 @@
           <p:cNvPr id="15" name="">
             <a:extLst xmlns:a="http://schemas.openxmlformats.org/drawingml/2006/main">
               <a:ext uri="{FF2B5EF4-FFF2-40B4-BE49-F238E27FC236}">
-                <a16:creationId xmlns:a16="http://schemas.microsoft.com/office/drawing/2014/main" id="{2EB7DB58-CBB5-4867-81E5-B55212B6E426}"/>
+                <a16:creationId xmlns:a16="http://schemas.microsoft.com/office/drawing/2014/main" id="{273B3CB6-8B27-4F39-855E-24B90FD41693}"/>
               </a:ext>
             </a:extLst>
           </p:cNvPr>
@@ -3977,7 +3977,7 @@
           <p:cNvPr id="16" name="">
             <a:extLst xmlns:a="http://schemas.openxmlformats.org/drawingml/2006/main">
               <a:ext uri="{FF2B5EF4-FFF2-40B4-BE49-F238E27FC236}">
-                <a16:creationId xmlns:a16="http://schemas.microsoft.com/office/drawing/2014/main" id="{9C91557C-4549-4933-99FA-B635854D837B}"/>
+                <a16:creationId xmlns:a16="http://schemas.microsoft.com/office/drawing/2014/main" id="{D7D00C55-CFA3-4502-98CA-B7AF83FA30F8}"/>
               </a:ext>
             </a:extLst>
           </p:cNvPr>
@@ -4034,7 +4034,7 @@
           <p:cNvPr id="17" name="">
             <a:extLst xmlns:a="http://schemas.openxmlformats.org/drawingml/2006/main">
               <a:ext uri="{FF2B5EF4-FFF2-40B4-BE49-F238E27FC236}">
-                <a16:creationId xmlns:a16="http://schemas.microsoft.com/office/drawing/2014/main" id="{BD89A1FB-A882-4324-8780-9792949239C1}"/>
+                <a16:creationId xmlns:a16="http://schemas.microsoft.com/office/drawing/2014/main" id="{4CD0F048-D970-4D90-8A53-1B30C4B88C26}"/>
               </a:ext>
             </a:extLst>
           </p:cNvPr>
@@ -4064,7 +4064,7 @@
           <p:cNvPr id="18" name="">
             <a:extLst xmlns:a="http://schemas.openxmlformats.org/drawingml/2006/main">
               <a:ext uri="{FF2B5EF4-FFF2-40B4-BE49-F238E27FC236}">
-                <a16:creationId xmlns:a16="http://schemas.microsoft.com/office/drawing/2014/main" id="{3F18A74E-8EA3-4A8D-A296-13F52D7AB823}"/>
+                <a16:creationId xmlns:a16="http://schemas.microsoft.com/office/drawing/2014/main" id="{3F0C6AC9-5E46-402D-9632-AA3E4DE3E4A2}"/>
               </a:ext>
             </a:extLst>
           </p:cNvPr>
@@ -4121,7 +4121,7 @@
           <p:cNvPr id="19" name="">
             <a:extLst xmlns:a="http://schemas.openxmlformats.org/drawingml/2006/main">
               <a:ext uri="{FF2B5EF4-FFF2-40B4-BE49-F238E27FC236}">
-                <a16:creationId xmlns:a16="http://schemas.microsoft.com/office/drawing/2014/main" id="{77EE70D2-2A8C-4567-AB9D-A75FE127B4A8}"/>
+                <a16:creationId xmlns:a16="http://schemas.microsoft.com/office/drawing/2014/main" id="{5B28AE7A-1688-4229-8652-6D1B04CE60E7}"/>
               </a:ext>
             </a:extLst>
           </p:cNvPr>
@@ -4151,7 +4151,7 @@
           <p:cNvPr id="20" name="">
             <a:extLst xmlns:a="http://schemas.openxmlformats.org/drawingml/2006/main">
               <a:ext uri="{FF2B5EF4-FFF2-40B4-BE49-F238E27FC236}">
-                <a16:creationId xmlns:a16="http://schemas.microsoft.com/office/drawing/2014/main" id="{D3696093-DE6B-42DF-BD2F-220F833F6A25}"/>
+                <a16:creationId xmlns:a16="http://schemas.microsoft.com/office/drawing/2014/main" id="{E3FABD1D-89BC-4287-9EC1-D3B201821ABA}"/>
               </a:ext>
             </a:extLst>
           </p:cNvPr>
@@ -4208,7 +4208,7 @@
           <p:cNvPr id="21" name="">
             <a:extLst xmlns:a="http://schemas.openxmlformats.org/drawingml/2006/main">
               <a:ext uri="{FF2B5EF4-FFF2-40B4-BE49-F238E27FC236}">
-                <a16:creationId xmlns:a16="http://schemas.microsoft.com/office/drawing/2014/main" id="{CDCDFAC6-9397-446A-A7C5-DF43E8B9DA90}"/>
+                <a16:creationId xmlns:a16="http://schemas.microsoft.com/office/drawing/2014/main" id="{57025829-882C-4AC5-94C4-871710104364}"/>
               </a:ext>
             </a:extLst>
           </p:cNvPr>
@@ -4265,36 +4265,36 @@
           <p:cNvPr id="22" name="">
             <a:extLst xmlns:a="http://schemas.openxmlformats.org/drawingml/2006/main">
               <a:ext uri="{FF2B5EF4-FFF2-40B4-BE49-F238E27FC236}">
-                <a16:creationId xmlns:a16="http://schemas.microsoft.com/office/drawing/2014/main" id="{F5CFDB35-1561-4F66-9344-349447671B16}"/>
-              </a:ext>
-            </a:extLst>
-          </p:cNvPr>
-          <p:cNvSpPr>
-            <a:spLocks xmlns:a="http://schemas.openxmlformats.org/drawingml/2006/main" noGrp="1"/>
-          </p:cNvSpPr>
-          <p:nvPr/>
-        </p:nvSpPr>
-        <p:spPr>
-          <a:xfrm xmlns:a="http://schemas.openxmlformats.org/drawingml/2006/main">
-            <a:off x="952500" y="6219825"/>
-            <a:ext cx="3333750" cy="285750"/>
-          </a:xfrm>
-          <a:prstGeom xmlns:a="http://schemas.openxmlformats.org/drawingml/2006/main" prst="rect">
-            <a:avLst/>
-          </a:prstGeom>
-          <a:noFill xmlns:a="http://schemas.openxmlformats.org/drawingml/2006/main"/>
-          <a:ln xmlns:a="http://schemas.openxmlformats.org/drawingml/2006/main" w="0">
-            <a:noFill/>
-          </a:ln>
-        </p:spPr>
-        <p:txBody>
-          <a:bodyPr xmlns:a="http://schemas.openxmlformats.org/drawingml/2006/main" anchor="ctr">
-            <a:normAutofit fontScale="94444"/>
+                <a16:creationId xmlns:a16="http://schemas.microsoft.com/office/drawing/2014/main" id="{77B4F2FE-8286-4F86-9CA4-D1221D3886DE}"/>
+              </a:ext>
+            </a:extLst>
+          </p:cNvPr>
+          <p:cNvSpPr>
+            <a:spLocks xmlns:a="http://schemas.openxmlformats.org/drawingml/2006/main" noGrp="1"/>
+          </p:cNvSpPr>
+          <p:nvPr/>
+        </p:nvSpPr>
+        <p:spPr>
+          <a:xfrm xmlns:a="http://schemas.openxmlformats.org/drawingml/2006/main">
+            <a:off x="666750" y="6219825"/>
+            <a:ext cx="4000500" cy="285750"/>
+          </a:xfrm>
+          <a:prstGeom xmlns:a="http://schemas.openxmlformats.org/drawingml/2006/main" prst="rect">
+            <a:avLst/>
+          </a:prstGeom>
+          <a:noFill xmlns:a="http://schemas.openxmlformats.org/drawingml/2006/main"/>
+          <a:ln xmlns:a="http://schemas.openxmlformats.org/drawingml/2006/main" w="0">
+            <a:noFill/>
+          </a:ln>
+        </p:spPr>
+        <p:txBody>
+          <a:bodyPr xmlns:a="http://schemas.openxmlformats.org/drawingml/2006/main" anchor="ctr">
+            <a:normAutofit fontScale="100000"/>
           </a:bodyPr>
           <a:lstStyle xmlns:a="http://schemas.openxmlformats.org/drawingml/2006/main"/>
           <a:p xmlns:a="http://schemas.openxmlformats.org/drawingml/2006/main">
             <a:pPr algn="ctr">
-              <a:defRPr sz="1350" b="0">
+              <a:defRPr sz="1275" b="0">
                 <a:solidFill>
                   <a:srgbClr val="64748B"/>
                 </a:solidFill>
@@ -4304,7 +4304,7 @@
               </a:defRPr>
             </a:pPr>
             <a:r>
-              <a:rPr sz="1350" b="0">
+              <a:rPr sz="1275" b="0">
                 <a:solidFill>
                   <a:srgbClr val="64748B"/>
                 </a:solidFill>
@@ -4312,7 +4312,7 @@
                 <a:ea typeface="Aptos"/>
                 <a:cs typeface="Aptos"/>
               </a:rPr>
-              <a:t>Select the parent once</a:t>
+              <a:t>Parent selection includes supported descendants</a:t>
             </a:r>
           </a:p>
         </p:txBody>
@@ -4322,7 +4322,7 @@
           <p:cNvPr id="23" name="">
             <a:extLst xmlns:a="http://schemas.openxmlformats.org/drawingml/2006/main">
               <a:ext uri="{FF2B5EF4-FFF2-40B4-BE49-F238E27FC236}">
-                <a16:creationId xmlns:a16="http://schemas.microsoft.com/office/drawing/2014/main" id="{3D05F6F7-529A-40EB-BE0D-2A6119F5ED22}"/>
+                <a16:creationId xmlns:a16="http://schemas.microsoft.com/office/drawing/2014/main" id="{FB52C1BE-78F5-463E-8798-A2600A954237}"/>
               </a:ext>
             </a:extLst>
           </p:cNvPr>
@@ -4351,7 +4351,7 @@
           <a:lstStyle xmlns:a="http://schemas.openxmlformats.org/drawingml/2006/main"/>
           <a:p xmlns:a="http://schemas.openxmlformats.org/drawingml/2006/main">
             <a:pPr algn="ctr">
-              <a:defRPr sz="1650" b="1">
+              <a:defRPr sz="1575" b="1">
                 <a:solidFill>
                   <a:srgbClr val="10213E"/>
                 </a:solidFill>
@@ -4361,7 +4361,7 @@
               </a:defRPr>
             </a:pPr>
             <a:r>
-              <a:rPr sz="1650" b="1">
+              <a:rPr sz="1575" b="1">
                 <a:solidFill>
                   <a:srgbClr val="10213E"/>
                 </a:solidFill>
@@ -4369,7 +4369,7 @@
                 <a:ea typeface="Aptos"/>
                 <a:cs typeface="Aptos"/>
               </a:rPr>
-              <a:t>Linked items follow their mapped IDs</a:t>
+              <a:t>Relationships use mapped destination IDs</a:t>
             </a:r>
           </a:p>
         </p:txBody>
@@ -4379,7 +4379,7 @@
           <p:cNvPr id="24" name="">
             <a:extLst xmlns:a="http://schemas.openxmlformats.org/drawingml/2006/main">
               <a:ext uri="{FF2B5EF4-FFF2-40B4-BE49-F238E27FC236}">
-                <a16:creationId xmlns:a16="http://schemas.microsoft.com/office/drawing/2014/main" id="{1619F605-0113-4CFD-A5A5-578D0F027E0A}"/>
+                <a16:creationId xmlns:a16="http://schemas.microsoft.com/office/drawing/2014/main" id="{7103930C-956C-49AC-BD52-7319007F334D}"/>
               </a:ext>
             </a:extLst>
           </p:cNvPr>
@@ -4434,7 +4434,7 @@
     </p:spTree>
     <p:extLst>
       <p:ext uri="{BB962C8B-B14F-4D97-AF65-F5344CB8AC3E}">
-        <p14:creationId xmlns:p14="http://schemas.microsoft.com/office/powerpoint/2010/main" val="821003368"/>
+        <p14:creationId xmlns:p14="http://schemas.microsoft.com/office/powerpoint/2010/main" val="448355432"/>
       </p:ext>
     </p:extLst>
   </p:cSld>
@@ -4465,7 +4465,7 @@
           <p:cNvPr id="20" name="">
             <a:extLst xmlns:a="http://schemas.openxmlformats.org/drawingml/2006/main">
               <a:ext uri="{FF2B5EF4-FFF2-40B4-BE49-F238E27FC236}">
-                <a16:creationId xmlns:a16="http://schemas.microsoft.com/office/drawing/2014/main" id="{2654197A-1BDB-4EC5-A9C0-89C38EEED73A}"/>
+                <a16:creationId xmlns:a16="http://schemas.microsoft.com/office/drawing/2014/main" id="{2A448AAA-5277-41CF-ABA9-F420E6FC1F88}"/>
               </a:ext>
             </a:extLst>
           </p:cNvPr>
@@ -4512,7 +4512,7 @@
                 <a:ea typeface="Aptos"/>
                 <a:cs typeface="Aptos"/>
               </a:rPr>
-              <a:t>Controlled by design</a:t>
+              <a:t>Governance and safeguards</a:t>
             </a:r>
           </a:p>
         </p:txBody>
@@ -4522,7 +4522,7 @@
           <p:cNvPr id="2" name="">
             <a:extLst xmlns:a="http://schemas.openxmlformats.org/drawingml/2006/main">
               <a:ext uri="{FF2B5EF4-FFF2-40B4-BE49-F238E27FC236}">
-                <a16:creationId xmlns:a16="http://schemas.microsoft.com/office/drawing/2014/main" id="{7AE924FA-F8CA-4EA5-ABEB-DCBA32BEE03E}"/>
+                <a16:creationId xmlns:a16="http://schemas.microsoft.com/office/drawing/2014/main" id="{22FCB56B-C406-4C52-A96B-2AD87F0C1644}"/>
               </a:ext>
             </a:extLst>
           </p:cNvPr>
@@ -4579,7 +4579,7 @@
           <p:cNvPr id="3" name="">
             <a:extLst xmlns:a="http://schemas.openxmlformats.org/drawingml/2006/main">
               <a:ext uri="{FF2B5EF4-FFF2-40B4-BE49-F238E27FC236}">
-                <a16:creationId xmlns:a16="http://schemas.microsoft.com/office/drawing/2014/main" id="{B4FD75B4-C6E7-4F64-89FC-C001409F10B0}"/>
+                <a16:creationId xmlns:a16="http://schemas.microsoft.com/office/drawing/2014/main" id="{02416F3E-44DD-4D06-9B79-2C31355E7E5A}"/>
               </a:ext>
             </a:extLst>
           </p:cNvPr>
@@ -4609,7 +4609,7 @@
           <p:cNvPr id="4" name="">
             <a:extLst xmlns:a="http://schemas.openxmlformats.org/drawingml/2006/main">
               <a:ext uri="{FF2B5EF4-FFF2-40B4-BE49-F238E27FC236}">
-                <a16:creationId xmlns:a16="http://schemas.microsoft.com/office/drawing/2014/main" id="{1B82EDF2-E1D7-4B54-B349-70E4414437C9}"/>
+                <a16:creationId xmlns:a16="http://schemas.microsoft.com/office/drawing/2014/main" id="{0D357192-1D86-4460-A5B3-2A78C1A2DD84}"/>
               </a:ext>
             </a:extLst>
           </p:cNvPr>
@@ -4656,7 +4656,7 @@
                 <a:ea typeface="Aptos"/>
                 <a:cs typeface="Aptos"/>
               </a:rPr>
-              <a:t>No duplicate surprises</a:t>
+              <a:t>Mapping integrity</a:t>
             </a:r>
           </a:p>
         </p:txBody>
@@ -4666,7 +4666,7 @@
           <p:cNvPr id="5" name="">
             <a:extLst xmlns:a="http://schemas.openxmlformats.org/drawingml/2006/main">
               <a:ext uri="{FF2B5EF4-FFF2-40B4-BE49-F238E27FC236}">
-                <a16:creationId xmlns:a16="http://schemas.microsoft.com/office/drawing/2014/main" id="{A53BD2DD-5F48-42FB-8196-AD52F86C0F15}"/>
+                <a16:creationId xmlns:a16="http://schemas.microsoft.com/office/drawing/2014/main" id="{B7810C04-8D4D-4947-B388-0A5FA11AFFB7}"/>
               </a:ext>
             </a:extLst>
           </p:cNvPr>
@@ -4713,7 +4713,7 @@
                 <a:ea typeface="Aptos"/>
                 <a:cs typeface="Aptos"/>
               </a:rPr>
-              <a:t>Exact match and saved ID mapping</a:t>
+              <a:t>Persistent source-to-destination ID mappings</a:t>
             </a:r>
           </a:p>
         </p:txBody>
@@ -4723,7 +4723,7 @@
           <p:cNvPr id="6" name="">
             <a:extLst xmlns:a="http://schemas.openxmlformats.org/drawingml/2006/main">
               <a:ext uri="{FF2B5EF4-FFF2-40B4-BE49-F238E27FC236}">
-                <a16:creationId xmlns:a16="http://schemas.microsoft.com/office/drawing/2014/main" id="{F7263E7B-9C0D-4172-9C69-1AF9FDE00899}"/>
+                <a16:creationId xmlns:a16="http://schemas.microsoft.com/office/drawing/2014/main" id="{BFADD036-715D-4358-9CB4-F623A124831F}"/>
               </a:ext>
             </a:extLst>
           </p:cNvPr>
@@ -4780,7 +4780,7 @@
           <p:cNvPr id="7" name="">
             <a:extLst xmlns:a="http://schemas.openxmlformats.org/drawingml/2006/main">
               <a:ext uri="{FF2B5EF4-FFF2-40B4-BE49-F238E27FC236}">
-                <a16:creationId xmlns:a16="http://schemas.microsoft.com/office/drawing/2014/main" id="{4C4B1EC5-BDED-45EF-B7D1-B3599FD04878}"/>
+                <a16:creationId xmlns:a16="http://schemas.microsoft.com/office/drawing/2014/main" id="{3E812356-38C5-4170-A175-9CD95F2A888A}"/>
               </a:ext>
             </a:extLst>
           </p:cNvPr>
@@ -4810,7 +4810,7 @@
           <p:cNvPr id="8" name="">
             <a:extLst xmlns:a="http://schemas.openxmlformats.org/drawingml/2006/main">
               <a:ext uri="{FF2B5EF4-FFF2-40B4-BE49-F238E27FC236}">
-                <a16:creationId xmlns:a16="http://schemas.microsoft.com/office/drawing/2014/main" id="{B11CF6F2-2475-498E-B45B-215C0F88A93C}"/>
+                <a16:creationId xmlns:a16="http://schemas.microsoft.com/office/drawing/2014/main" id="{13B6892D-362A-4E1B-A2CC-2887502AFA9A}"/>
               </a:ext>
             </a:extLst>
           </p:cNvPr>
@@ -4857,7 +4857,7 @@
                 <a:ea typeface="Aptos"/>
                 <a:cs typeface="Aptos"/>
               </a:rPr>
-              <a:t>Destination workflow protected</a:t>
+              <a:t>Workflow protection</a:t>
             </a:r>
           </a:p>
         </p:txBody>
@@ -4867,7 +4867,7 @@
           <p:cNvPr id="9" name="">
             <a:extLst xmlns:a="http://schemas.openxmlformats.org/drawingml/2006/main">
               <a:ext uri="{FF2B5EF4-FFF2-40B4-BE49-F238E27FC236}">
-                <a16:creationId xmlns:a16="http://schemas.microsoft.com/office/drawing/2014/main" id="{2A2249D2-737A-4E21-83A8-53BF36B6C132}"/>
+                <a16:creationId xmlns:a16="http://schemas.microsoft.com/office/drawing/2014/main" id="{9F69E52B-E59B-4CAA-907C-5D03D4519B00}"/>
               </a:ext>
             </a:extLst>
           </p:cNvPr>
@@ -4914,7 +4914,7 @@
                 <a:ea typeface="Aptos"/>
                 <a:cs typeface="Aptos"/>
               </a:rPr>
-              <a:t>State never changes</a:t>
+              <a:t>Destination state remains unchanged</a:t>
             </a:r>
           </a:p>
         </p:txBody>
@@ -4924,7 +4924,7 @@
           <p:cNvPr id="10" name="">
             <a:extLst xmlns:a="http://schemas.openxmlformats.org/drawingml/2006/main">
               <a:ext uri="{FF2B5EF4-FFF2-40B4-BE49-F238E27FC236}">
-                <a16:creationId xmlns:a16="http://schemas.microsoft.com/office/drawing/2014/main" id="{364A17C8-AB4B-49C7-8CE6-8CC8821183BE}"/>
+                <a16:creationId xmlns:a16="http://schemas.microsoft.com/office/drawing/2014/main" id="{50119E9B-922E-4D29-B518-22437438239A}"/>
               </a:ext>
             </a:extLst>
           </p:cNvPr>
@@ -4981,7 +4981,7 @@
           <p:cNvPr id="11" name="">
             <a:extLst xmlns:a="http://schemas.openxmlformats.org/drawingml/2006/main">
               <a:ext uri="{FF2B5EF4-FFF2-40B4-BE49-F238E27FC236}">
-                <a16:creationId xmlns:a16="http://schemas.microsoft.com/office/drawing/2014/main" id="{CECFFF89-E687-4C0E-9568-71B2464DEB7F}"/>
+                <a16:creationId xmlns:a16="http://schemas.microsoft.com/office/drawing/2014/main" id="{E93F9033-4DCC-494F-9765-E6A56D413AC4}"/>
               </a:ext>
             </a:extLst>
           </p:cNvPr>
@@ -5011,7 +5011,7 @@
           <p:cNvPr id="12" name="">
             <a:extLst xmlns:a="http://schemas.openxmlformats.org/drawingml/2006/main">
               <a:ext uri="{FF2B5EF4-FFF2-40B4-BE49-F238E27FC236}">
-                <a16:creationId xmlns:a16="http://schemas.microsoft.com/office/drawing/2014/main" id="{5F7B3DA3-01C9-4B56-99D2-605392183EB6}"/>
+                <a16:creationId xmlns:a16="http://schemas.microsoft.com/office/drawing/2014/main" id="{B0E64344-2482-45D4-8356-C4A256805E93}"/>
               </a:ext>
             </a:extLst>
           </p:cNvPr>
@@ -5058,7 +5058,7 @@
                 <a:ea typeface="Aptos"/>
                 <a:cs typeface="Aptos"/>
               </a:rPr>
-              <a:t>Credentials stay secure</a:t>
+              <a:t>Credential protection</a:t>
             </a:r>
           </a:p>
         </p:txBody>
@@ -5068,7 +5068,7 @@
           <p:cNvPr id="13" name="">
             <a:extLst xmlns:a="http://schemas.openxmlformats.org/drawingml/2006/main">
               <a:ext uri="{FF2B5EF4-FFF2-40B4-BE49-F238E27FC236}">
-                <a16:creationId xmlns:a16="http://schemas.microsoft.com/office/drawing/2014/main" id="{8E16AC3B-3617-4811-B832-71A97B1761CB}"/>
+                <a16:creationId xmlns:a16="http://schemas.microsoft.com/office/drawing/2014/main" id="{69878688-A73B-4D02-9D0C-69EA86C719E6}"/>
               </a:ext>
             </a:extLst>
           </p:cNvPr>
@@ -5115,7 +5115,7 @@
                 <a:ea typeface="Aptos"/>
                 <a:cs typeface="Aptos"/>
               </a:rPr>
-              <a:t>Session only or Windows Credential Manager</a:t>
+              <a:t>Session memory or Windows Credential Manager</a:t>
             </a:r>
           </a:p>
         </p:txBody>
@@ -5125,7 +5125,7 @@
           <p:cNvPr id="14" name="">
             <a:extLst xmlns:a="http://schemas.openxmlformats.org/drawingml/2006/main">
               <a:ext uri="{FF2B5EF4-FFF2-40B4-BE49-F238E27FC236}">
-                <a16:creationId xmlns:a16="http://schemas.microsoft.com/office/drawing/2014/main" id="{23E08D71-45DC-4AE6-872E-1FFDD9091FF6}"/>
+                <a16:creationId xmlns:a16="http://schemas.microsoft.com/office/drawing/2014/main" id="{2252A1A6-4083-4824-8272-10A09AEA44E8}"/>
               </a:ext>
             </a:extLst>
           </p:cNvPr>
@@ -5182,7 +5182,7 @@
           <p:cNvPr id="15" name="">
             <a:extLst xmlns:a="http://schemas.openxmlformats.org/drawingml/2006/main">
               <a:ext uri="{FF2B5EF4-FFF2-40B4-BE49-F238E27FC236}">
-                <a16:creationId xmlns:a16="http://schemas.microsoft.com/office/drawing/2014/main" id="{577054AE-B1B5-4B52-B0F7-01C7385E7752}"/>
+                <a16:creationId xmlns:a16="http://schemas.microsoft.com/office/drawing/2014/main" id="{8529F385-1695-4D33-9C0C-F9D0A9D790AF}"/>
               </a:ext>
             </a:extLst>
           </p:cNvPr>
@@ -5212,7 +5212,7 @@
           <p:cNvPr id="16" name="">
             <a:extLst xmlns:a="http://schemas.openxmlformats.org/drawingml/2006/main">
               <a:ext uri="{FF2B5EF4-FFF2-40B4-BE49-F238E27FC236}">
-                <a16:creationId xmlns:a16="http://schemas.microsoft.com/office/drawing/2014/main" id="{82A16AD3-A2E3-41CB-BDE4-07D99E70C690}"/>
+                <a16:creationId xmlns:a16="http://schemas.microsoft.com/office/drawing/2014/main" id="{0A5D86F5-1629-4B5A-80A7-7796269C194F}"/>
               </a:ext>
             </a:extLst>
           </p:cNvPr>
@@ -5259,7 +5259,7 @@
                 <a:ea typeface="Aptos"/>
                 <a:cs typeface="Aptos"/>
               </a:rPr>
-              <a:t>Every run leaves evidence</a:t>
+              <a:t>Run traceability</a:t>
             </a:r>
           </a:p>
         </p:txBody>
@@ -5269,7 +5269,7 @@
           <p:cNvPr id="17" name="">
             <a:extLst xmlns:a="http://schemas.openxmlformats.org/drawingml/2006/main">
               <a:ext uri="{FF2B5EF4-FFF2-40B4-BE49-F238E27FC236}">
-                <a16:creationId xmlns:a16="http://schemas.microsoft.com/office/drawing/2014/main" id="{15D41FB7-35E0-49D3-9301-6902E52A829E}"/>
+                <a16:creationId xmlns:a16="http://schemas.microsoft.com/office/drawing/2014/main" id="{249D483E-B7D6-4FBA-916F-84269593C024}"/>
               </a:ext>
             </a:extLst>
           </p:cNvPr>
@@ -5316,7 +5316,7 @@
                 <a:ea typeface="Aptos"/>
                 <a:cs typeface="Aptos"/>
               </a:rPr>
-              <a:t>Destination IDs, errors and export logs</a:t>
+              <a:t>Destination IDs, errors and exportable logs</a:t>
             </a:r>
           </a:p>
         </p:txBody>
@@ -5326,7 +5326,7 @@
           <p:cNvPr id="18" name="">
             <a:extLst xmlns:a="http://schemas.openxmlformats.org/drawingml/2006/main">
               <a:ext uri="{FF2B5EF4-FFF2-40B4-BE49-F238E27FC236}">
-                <a16:creationId xmlns:a16="http://schemas.microsoft.com/office/drawing/2014/main" id="{D02A295B-60C5-4E9E-B0EA-0FB4D54AA462}"/>
+                <a16:creationId xmlns:a16="http://schemas.microsoft.com/office/drawing/2014/main" id="{0E6ACAEC-239A-46D2-9569-DBFD0B705A2C}"/>
               </a:ext>
             </a:extLst>
           </p:cNvPr>
@@ -5383,7 +5383,7 @@
           <p:cNvPr id="19" name="">
             <a:extLst xmlns:a="http://schemas.openxmlformats.org/drawingml/2006/main">
               <a:ext uri="{FF2B5EF4-FFF2-40B4-BE49-F238E27FC236}">
-                <a16:creationId xmlns:a16="http://schemas.microsoft.com/office/drawing/2014/main" id="{E4E8A371-8184-4239-B39F-5CE4D536A535}"/>
+                <a16:creationId xmlns:a16="http://schemas.microsoft.com/office/drawing/2014/main" id="{1F69C9E0-E5C7-4EEF-A957-273AC6E19F5E}"/>
               </a:ext>
             </a:extLst>
           </p:cNvPr>
@@ -5438,7 +5438,7 @@
     </p:spTree>
     <p:extLst>
       <p:ext uri="{BB962C8B-B14F-4D97-AF65-F5344CB8AC3E}">
-        <p14:creationId xmlns:p14="http://schemas.microsoft.com/office/powerpoint/2010/main" val="1179151941"/>
+        <p14:creationId xmlns:p14="http://schemas.microsoft.com/office/powerpoint/2010/main" val="427023099"/>
       </p:ext>
     </p:extLst>
   </p:cSld>
@@ -5469,7 +5469,7 @@
           <p:cNvPr id="19" name="">
             <a:extLst xmlns:a="http://schemas.openxmlformats.org/drawingml/2006/main">
               <a:ext uri="{FF2B5EF4-FFF2-40B4-BE49-F238E27FC236}">
-                <a16:creationId xmlns:a16="http://schemas.microsoft.com/office/drawing/2014/main" id="{0686B6F9-2B50-41A5-A3B7-6F9F127B942F}"/>
+                <a16:creationId xmlns:a16="http://schemas.microsoft.com/office/drawing/2014/main" id="{8130ED92-73AB-41C2-B80F-F4EF204B0C24}"/>
               </a:ext>
             </a:extLst>
           </p:cNvPr>
@@ -5481,7 +5481,7 @@
         <p:spPr>
           <a:xfrm xmlns:a="http://schemas.openxmlformats.org/drawingml/2006/main">
             <a:off x="704850" y="514350"/>
-            <a:ext cx="2095500" cy="247650"/>
+            <a:ext cx="2476500" cy="247650"/>
           </a:xfrm>
           <a:prstGeom xmlns:a="http://schemas.openxmlformats.org/drawingml/2006/main" prst="rect">
             <a:avLst/>
@@ -5516,7 +5516,7 @@
                 <a:ea typeface="Aptos"/>
                 <a:cs typeface="Aptos"/>
               </a:rPr>
-              <a:t>LIVE DEMO</a:t>
+              <a:t>LIVE DEMONSTRATION</a:t>
             </a:r>
           </a:p>
         </p:txBody>
@@ -5526,7 +5526,7 @@
           <p:cNvPr id="2" name="">
             <a:extLst xmlns:a="http://schemas.openxmlformats.org/drawingml/2006/main">
               <a:ext uri="{FF2B5EF4-FFF2-40B4-BE49-F238E27FC236}">
-                <a16:creationId xmlns:a16="http://schemas.microsoft.com/office/drawing/2014/main" id="{17E8D47C-25BA-48B4-B68C-6BFC6585AAA1}"/>
+                <a16:creationId xmlns:a16="http://schemas.microsoft.com/office/drawing/2014/main" id="{9F78744B-F91A-434F-88DC-C3107351C3A8}"/>
               </a:ext>
             </a:extLst>
           </p:cNvPr>
@@ -5538,7 +5538,7 @@
         <p:spPr>
           <a:xfrm xmlns:a="http://schemas.openxmlformats.org/drawingml/2006/main">
             <a:off x="704850" y="1000125"/>
-            <a:ext cx="7810500" cy="742950"/>
+            <a:ext cx="8763000" cy="742950"/>
           </a:xfrm>
           <a:prstGeom xmlns:a="http://schemas.openxmlformats.org/drawingml/2006/main" prst="rect">
             <a:avLst/>
@@ -5555,7 +5555,7 @@
           <a:lstStyle xmlns:a="http://schemas.openxmlformats.org/drawingml/2006/main"/>
           <a:p xmlns:a="http://schemas.openxmlformats.org/drawingml/2006/main">
             <a:pPr algn="l">
-              <a:defRPr sz="3300" b="1">
+              <a:defRPr sz="3150" b="1">
                 <a:solidFill>
                   <a:srgbClr val="10213E"/>
                 </a:solidFill>
@@ -5565,7 +5565,7 @@
               </a:defRPr>
             </a:pPr>
             <a:r>
-              <a:rPr sz="3300" b="1">
+              <a:rPr sz="3150" b="1">
                 <a:solidFill>
                   <a:srgbClr val="10213E"/>
                 </a:solidFill>
@@ -5573,7 +5573,7 @@
                 <a:ea typeface="Aptos"/>
                 <a:cs typeface="Aptos"/>
               </a:rPr>
-              <a:t>Watch one change travel</a:t>
+              <a:t>Live synchronization demonstration</a:t>
             </a:r>
           </a:p>
         </p:txBody>
@@ -5583,7 +5583,7 @@
           <p:cNvPr id="3" name="">
             <a:extLst xmlns:a="http://schemas.openxmlformats.org/drawingml/2006/main">
               <a:ext uri="{FF2B5EF4-FFF2-40B4-BE49-F238E27FC236}">
-                <a16:creationId xmlns:a16="http://schemas.microsoft.com/office/drawing/2014/main" id="{D4721CD9-5238-45AB-BBFF-CE272C0B3761}"/>
+                <a16:creationId xmlns:a16="http://schemas.microsoft.com/office/drawing/2014/main" id="{8991E3E2-4F65-4161-B5D5-B2C64C979819}"/>
               </a:ext>
             </a:extLst>
           </p:cNvPr>
@@ -5613,7 +5613,7 @@
           <p:cNvPr id="4" name="">
             <a:extLst xmlns:a="http://schemas.openxmlformats.org/drawingml/2006/main">
               <a:ext uri="{FF2B5EF4-FFF2-40B4-BE49-F238E27FC236}">
-                <a16:creationId xmlns:a16="http://schemas.microsoft.com/office/drawing/2014/main" id="{3322A6E1-5DEB-439D-93A9-86C38B1853E2}"/>
+                <a16:creationId xmlns:a16="http://schemas.microsoft.com/office/drawing/2014/main" id="{4828AD14-7CE1-4A0D-83DB-4E9650B143A2}"/>
               </a:ext>
             </a:extLst>
           </p:cNvPr>
@@ -5643,7 +5643,7 @@
           <p:cNvPr id="5" name="">
             <a:extLst xmlns:a="http://schemas.openxmlformats.org/drawingml/2006/main">
               <a:ext uri="{FF2B5EF4-FFF2-40B4-BE49-F238E27FC236}">
-                <a16:creationId xmlns:a16="http://schemas.microsoft.com/office/drawing/2014/main" id="{201479AB-420F-4108-BF78-1E51F88C2BEB}"/>
+                <a16:creationId xmlns:a16="http://schemas.microsoft.com/office/drawing/2014/main" id="{2D13B9AC-9B8B-4CA0-B951-1BEDC92BDB18}"/>
               </a:ext>
             </a:extLst>
           </p:cNvPr>
@@ -5667,7 +5667,7 @@
         </p:spPr>
         <p:txBody>
           <a:bodyPr xmlns:a="http://schemas.openxmlformats.org/drawingml/2006/main" anchor="ctr">
-            <a:normAutofit fontScale="100000"/>
+            <a:normAutofit fontScale="88159"/>
           </a:bodyPr>
           <a:lstStyle xmlns:a="http://schemas.openxmlformats.org/drawingml/2006/main"/>
           <a:p xmlns:a="http://schemas.openxmlformats.org/drawingml/2006/main">
@@ -5690,7 +5690,7 @@
                 <a:ea typeface="Aptos"/>
                 <a:cs typeface="Aptos"/>
               </a:rPr>
-              <a:t>Change</a:t>
+              <a:t>Source update</a:t>
             </a:r>
           </a:p>
         </p:txBody>
@@ -5700,7 +5700,7 @@
           <p:cNvPr id="6" name="">
             <a:extLst xmlns:a="http://schemas.openxmlformats.org/drawingml/2006/main">
               <a:ext uri="{FF2B5EF4-FFF2-40B4-BE49-F238E27FC236}">
-                <a16:creationId xmlns:a16="http://schemas.microsoft.com/office/drawing/2014/main" id="{EDC4F21B-593C-4219-8A64-FF37F6089420}"/>
+                <a16:creationId xmlns:a16="http://schemas.microsoft.com/office/drawing/2014/main" id="{63175785-B5FE-4F3A-84F6-F8C39BB164A5}"/>
               </a:ext>
             </a:extLst>
           </p:cNvPr>
@@ -5747,7 +5747,7 @@
                 <a:ea typeface="Aptos"/>
                 <a:cs typeface="Aptos"/>
               </a:rPr>
-              <a:t>Edit a source item</a:t>
+              <a:t>Modify a selected source field</a:t>
             </a:r>
           </a:p>
         </p:txBody>
@@ -5757,7 +5757,7 @@
           <p:cNvPr id="7" name="">
             <a:extLst xmlns:a="http://schemas.openxmlformats.org/drawingml/2006/main">
               <a:ext uri="{FF2B5EF4-FFF2-40B4-BE49-F238E27FC236}">
-                <a16:creationId xmlns:a16="http://schemas.microsoft.com/office/drawing/2014/main" id="{78E242DF-81F2-451E-BD88-1915B6136673}"/>
+                <a16:creationId xmlns:a16="http://schemas.microsoft.com/office/drawing/2014/main" id="{0933FD98-63C8-4AC8-8A40-E3B2FB1BDA41}"/>
               </a:ext>
             </a:extLst>
           </p:cNvPr>
@@ -5787,7 +5787,7 @@
           <p:cNvPr id="8" name="">
             <a:extLst xmlns:a="http://schemas.openxmlformats.org/drawingml/2006/main">
               <a:ext uri="{FF2B5EF4-FFF2-40B4-BE49-F238E27FC236}">
-                <a16:creationId xmlns:a16="http://schemas.microsoft.com/office/drawing/2014/main" id="{E870DC9F-8003-4BEA-823D-30BC8BDA0140}"/>
+                <a16:creationId xmlns:a16="http://schemas.microsoft.com/office/drawing/2014/main" id="{20825315-D64D-496F-9FDC-ECF074A77BEA}"/>
               </a:ext>
             </a:extLst>
           </p:cNvPr>
@@ -5834,7 +5834,7 @@
                 <a:ea typeface="Aptos"/>
                 <a:cs typeface="Aptos"/>
               </a:rPr>
-              <a:t>Check</a:t>
+              <a:t>Assessment</a:t>
             </a:r>
           </a:p>
         </p:txBody>
@@ -5844,7 +5844,7 @@
           <p:cNvPr id="9" name="">
             <a:extLst xmlns:a="http://schemas.openxmlformats.org/drawingml/2006/main">
               <a:ext uri="{FF2B5EF4-FFF2-40B4-BE49-F238E27FC236}">
-                <a16:creationId xmlns:a16="http://schemas.microsoft.com/office/drawing/2014/main" id="{0750ED44-87E0-4486-982E-463865AA1520}"/>
+                <a16:creationId xmlns:a16="http://schemas.microsoft.com/office/drawing/2014/main" id="{6A4FA258-F8A8-4E9B-8E2E-D0FF8C4FDCC4}"/>
               </a:ext>
             </a:extLst>
           </p:cNvPr>
@@ -5891,7 +5891,7 @@
                 <a:ea typeface="Aptos"/>
                 <a:cs typeface="Aptos"/>
               </a:rPr>
-              <a:t>Preview the difference</a:t>
+              <a:t>Preview the planned changes</a:t>
             </a:r>
           </a:p>
         </p:txBody>
@@ -5901,7 +5901,7 @@
           <p:cNvPr id="10" name="">
             <a:extLst xmlns:a="http://schemas.openxmlformats.org/drawingml/2006/main">
               <a:ext uri="{FF2B5EF4-FFF2-40B4-BE49-F238E27FC236}">
-                <a16:creationId xmlns:a16="http://schemas.microsoft.com/office/drawing/2014/main" id="{CE3A3348-047C-441C-9B4D-F121E8902B66}"/>
+                <a16:creationId xmlns:a16="http://schemas.microsoft.com/office/drawing/2014/main" id="{B0C3F902-98C7-4D2F-9EAE-B8C09BB65B42}"/>
               </a:ext>
             </a:extLst>
           </p:cNvPr>
@@ -5931,7 +5931,7 @@
           <p:cNvPr id="11" name="">
             <a:extLst xmlns:a="http://schemas.openxmlformats.org/drawingml/2006/main">
               <a:ext uri="{FF2B5EF4-FFF2-40B4-BE49-F238E27FC236}">
-                <a16:creationId xmlns:a16="http://schemas.microsoft.com/office/drawing/2014/main" id="{1917056A-B8C1-4195-AEC3-43C92C106A0C}"/>
+                <a16:creationId xmlns:a16="http://schemas.microsoft.com/office/drawing/2014/main" id="{30729D46-ADD3-447E-8D03-CB38C8FE882B}"/>
               </a:ext>
             </a:extLst>
           </p:cNvPr>
@@ -5978,7 +5978,7 @@
                 <a:ea typeface="Aptos"/>
                 <a:cs typeface="Aptos"/>
               </a:rPr>
-              <a:t>Sync</a:t>
+              <a:t>Execution</a:t>
             </a:r>
           </a:p>
         </p:txBody>
@@ -5988,7 +5988,7 @@
           <p:cNvPr id="12" name="">
             <a:extLst xmlns:a="http://schemas.openxmlformats.org/drawingml/2006/main">
               <a:ext uri="{FF2B5EF4-FFF2-40B4-BE49-F238E27FC236}">
-                <a16:creationId xmlns:a16="http://schemas.microsoft.com/office/drawing/2014/main" id="{387DCF8A-3232-44EB-9506-06D1BCE15DFE}"/>
+                <a16:creationId xmlns:a16="http://schemas.microsoft.com/office/drawing/2014/main" id="{9C9DFCD6-2B11-4F7A-B79B-5CDE1D346E54}"/>
               </a:ext>
             </a:extLst>
           </p:cNvPr>
@@ -6035,7 +6035,7 @@
                 <a:ea typeface="Aptos"/>
                 <a:cs typeface="Aptos"/>
               </a:rPr>
-              <a:t>Send it to destinations</a:t>
+              <a:t>Synchronize selected content</a:t>
             </a:r>
           </a:p>
         </p:txBody>
@@ -6045,7 +6045,7 @@
           <p:cNvPr id="13" name="">
             <a:extLst xmlns:a="http://schemas.openxmlformats.org/drawingml/2006/main">
               <a:ext uri="{FF2B5EF4-FFF2-40B4-BE49-F238E27FC236}">
-                <a16:creationId xmlns:a16="http://schemas.microsoft.com/office/drawing/2014/main" id="{126456DE-B575-4540-B54F-8C7245DBDFD6}"/>
+                <a16:creationId xmlns:a16="http://schemas.microsoft.com/office/drawing/2014/main" id="{BC3A65DF-41B5-4F36-AB7F-E224AB6341BF}"/>
               </a:ext>
             </a:extLst>
           </p:cNvPr>
@@ -6075,7 +6075,7 @@
           <p:cNvPr id="14" name="">
             <a:extLst xmlns:a="http://schemas.openxmlformats.org/drawingml/2006/main">
               <a:ext uri="{FF2B5EF4-FFF2-40B4-BE49-F238E27FC236}">
-                <a16:creationId xmlns:a16="http://schemas.microsoft.com/office/drawing/2014/main" id="{C1DDDD35-88B6-4B88-B3F4-1C6BF3D53E94}"/>
+                <a16:creationId xmlns:a16="http://schemas.microsoft.com/office/drawing/2014/main" id="{03EE1CB5-F3FD-45D8-97C5-109693E00F99}"/>
               </a:ext>
             </a:extLst>
           </p:cNvPr>
@@ -6122,7 +6122,7 @@
                 <a:ea typeface="Aptos"/>
                 <a:cs typeface="Aptos"/>
               </a:rPr>
-              <a:t>Verify</a:t>
+              <a:t>Validation</a:t>
             </a:r>
           </a:p>
         </p:txBody>
@@ -6132,7 +6132,7 @@
           <p:cNvPr id="15" name="">
             <a:extLst xmlns:a="http://schemas.openxmlformats.org/drawingml/2006/main">
               <a:ext uri="{FF2B5EF4-FFF2-40B4-BE49-F238E27FC236}">
-                <a16:creationId xmlns:a16="http://schemas.microsoft.com/office/drawing/2014/main" id="{DAAB6082-AF31-4555-AB46-D6E83A542623}"/>
+                <a16:creationId xmlns:a16="http://schemas.microsoft.com/office/drawing/2014/main" id="{58402436-D25D-4647-9CC8-FF12B054D2F2}"/>
               </a:ext>
             </a:extLst>
           </p:cNvPr>
@@ -6179,7 +6179,7 @@
                 <a:ea typeface="Aptos"/>
                 <a:cs typeface="Aptos"/>
               </a:rPr>
-              <a:t>IDs, links and logs</a:t>
+              <a:t>Confirm IDs, relationships and logs</a:t>
             </a:r>
           </a:p>
         </p:txBody>
@@ -6189,7 +6189,7 @@
           <p:cNvPr id="16" name="">
             <a:extLst xmlns:a="http://schemas.openxmlformats.org/drawingml/2006/main">
               <a:ext uri="{FF2B5EF4-FFF2-40B4-BE49-F238E27FC236}">
-                <a16:creationId xmlns:a16="http://schemas.microsoft.com/office/drawing/2014/main" id="{CF1EC1C1-B1C3-410B-B6E0-214EFC2E04AF}"/>
+                <a16:creationId xmlns:a16="http://schemas.microsoft.com/office/drawing/2014/main" id="{91D54862-C15B-4499-9160-D4C9E78ECA96}"/>
               </a:ext>
             </a:extLst>
           </p:cNvPr>
@@ -6201,7 +6201,7 @@
         <p:spPr>
           <a:xfrm xmlns:a="http://schemas.openxmlformats.org/drawingml/2006/main">
             <a:off x="704850" y="5810250"/>
-            <a:ext cx="4000500" cy="438150"/>
+            <a:ext cx="4476750" cy="438150"/>
           </a:xfrm>
           <a:prstGeom xmlns:a="http://schemas.openxmlformats.org/drawingml/2006/main" prst="rect">
             <a:avLst/>
@@ -6236,7 +6236,7 @@
                 <a:ea typeface="Aptos"/>
                 <a:cs typeface="Aptos"/>
               </a:rPr>
-              <a:t>Open SyncWorkTrack</a:t>
+              <a:t>Proceed to SyncWorkTrack</a:t>
             </a:r>
           </a:p>
         </p:txBody>
@@ -6246,19 +6246,19 @@
           <p:cNvPr id="17" name="">
             <a:extLst xmlns:a="http://schemas.openxmlformats.org/drawingml/2006/main">
               <a:ext uri="{FF2B5EF4-FFF2-40B4-BE49-F238E27FC236}">
-                <a16:creationId xmlns:a16="http://schemas.microsoft.com/office/drawing/2014/main" id="{4B49354D-A26D-41D8-A9B0-348F2EC42798}"/>
-              </a:ext>
-            </a:extLst>
-          </p:cNvPr>
-          <p:cNvSpPr>
-            <a:spLocks xmlns:a="http://schemas.openxmlformats.org/drawingml/2006/main" noGrp="1"/>
-          </p:cNvSpPr>
-          <p:nvPr/>
-        </p:nvSpPr>
-        <p:spPr>
-          <a:xfrm xmlns:a="http://schemas.openxmlformats.org/drawingml/2006/main">
-            <a:off x="7191375" y="5810250"/>
-            <a:ext cx="4000500" cy="438150"/>
+                <a16:creationId xmlns:a16="http://schemas.microsoft.com/office/drawing/2014/main" id="{8D54F3C6-CFB1-45B0-AE9A-CB73438E9697}"/>
+              </a:ext>
+            </a:extLst>
+          </p:cNvPr>
+          <p:cNvSpPr>
+            <a:spLocks xmlns:a="http://schemas.openxmlformats.org/drawingml/2006/main" noGrp="1"/>
+          </p:cNvSpPr>
+          <p:nvPr/>
+        </p:nvSpPr>
+        <p:spPr>
+          <a:xfrm xmlns:a="http://schemas.openxmlformats.org/drawingml/2006/main">
+            <a:off x="6477000" y="5810250"/>
+            <a:ext cx="4762500" cy="438150"/>
           </a:xfrm>
           <a:prstGeom xmlns:a="http://schemas.openxmlformats.org/drawingml/2006/main" prst="rect">
             <a:avLst/>
@@ -6275,7 +6275,7 @@
           <a:lstStyle xmlns:a="http://schemas.openxmlformats.org/drawingml/2006/main"/>
           <a:p xmlns:a="http://schemas.openxmlformats.org/drawingml/2006/main">
             <a:pPr algn="r">
-              <a:defRPr sz="1650" b="0">
+              <a:defRPr sz="1500" b="0">
                 <a:solidFill>
                   <a:srgbClr val="64748B"/>
                 </a:solidFill>
@@ -6285,7 +6285,7 @@
               </a:defRPr>
             </a:pPr>
             <a:r>
-              <a:rPr sz="1650" b="0">
+              <a:rPr sz="1500" b="0">
                 <a:solidFill>
                   <a:srgbClr val="64748B"/>
                 </a:solidFill>
@@ -6293,7 +6293,7 @@
                 <a:ea typeface="Aptos"/>
                 <a:cs typeface="Aptos"/>
               </a:rPr>
-              <a:t>The app carries the proof</a:t>
+              <a:t>Validate the expected results in Azure DevOps</a:t>
             </a:r>
           </a:p>
         </p:txBody>
@@ -6303,7 +6303,7 @@
           <p:cNvPr id="18" name="">
             <a:extLst xmlns:a="http://schemas.openxmlformats.org/drawingml/2006/main">
               <a:ext uri="{FF2B5EF4-FFF2-40B4-BE49-F238E27FC236}">
-                <a16:creationId xmlns:a16="http://schemas.microsoft.com/office/drawing/2014/main" id="{2859DBA1-8F85-4B28-9524-0CA1B44B4FB5}"/>
+                <a16:creationId xmlns:a16="http://schemas.microsoft.com/office/drawing/2014/main" id="{635B1A42-3FFD-4370-88F6-675E46FD902C}"/>
               </a:ext>
             </a:extLst>
           </p:cNvPr>
@@ -6358,7 +6358,7 @@
     </p:spTree>
     <p:extLst>
       <p:ext uri="{BB962C8B-B14F-4D97-AF65-F5344CB8AC3E}">
-        <p14:creationId xmlns:p14="http://schemas.microsoft.com/office/powerpoint/2010/main" val="1438566213"/>
+        <p14:creationId xmlns:p14="http://schemas.microsoft.com/office/powerpoint/2010/main" val="1107877763"/>
       </p:ext>
     </p:extLst>
   </p:cSld>

</xml_diff>